<commit_message>
Final (?) versions of ppt and html reports...
</commit_message>
<xml_diff>
--- a/NHP_SBR impacts_2024_summaryfinal.pptx
+++ b/NHP_SBR impacts_2024_summaryfinal.pptx
@@ -45,6 +45,7 @@
     <p:sldId id="293" r:id="rId42"/>
     <p:sldId id="294" r:id="rId43"/>
     <p:sldId id="295" r:id="rId44"/>
+    <p:sldId id="296" r:id="rId45"/>
   </p:sldIdLst>
   <p:sldSz cx="12192000" cy="6858000"/>
   <p:notesSz cx="6858000" cy="9144000"/>
@@ -4219,7 +4220,7 @@
             <a:br/>
             <a:r>
               <a:rPr/>
-              <a:t>Andy Hood | Analytics Manager | Strategy Unit | Oct 2024</a:t>
+              <a:t>Andy Hood | Analytics Manager | Strategy Unit | May 2025</a:t>
             </a:r>
           </a:p>
         </p:txBody>
@@ -4258,8 +4259,8 @@
         </p:nvSpPr>
         <p:spPr>
           <a:xfrm>
-            <a:off x="909829" y="403765"/>
-            <a:ext cx="8434196" cy="976056"/>
+            <a:off x="909829" y="438150"/>
+            <a:ext cx="8434196" cy="914400"/>
           </a:xfrm>
         </p:spPr>
         <p:txBody>
@@ -4271,19 +4272,25 @@
             </a:pPr>
             <a:r>
               <a:rPr/>
-              <a:t>2.5 Limitations</a:t>
-            </a:r>
-          </a:p>
-        </p:txBody>
-      </p:sp>
-      <p:sp>
-        <p:nvSpPr>
-          <p:cNvPr id="3" name="Content Placeholder 2"/>
-          <p:cNvSpPr>
-            <a:spLocks noGrp="1"/>
-          </p:cNvSpPr>
-          <p:nvPr>
-            <p:ph idx="1"/>
+              <a:t>2.4 Summary of key findings (2)</a:t>
+            </a:r>
+          </a:p>
+        </p:txBody>
+      </p:sp>
+      <p:sp>
+        <p:nvSpPr>
+          <p:cNvPr id="7" name="Text Placeholder 6">
+            <a:extLst>
+              <a:ext uri="{FF2B5EF4-FFF2-40B4-BE49-F238E27FC236}">
+                <a16:creationId xmlns:a16="http://schemas.microsoft.com/office/drawing/2014/main" id="{DE622849-4EA7-24AE-DD96-E693EAA81594}"/>
+              </a:ext>
+            </a:extLst>
+          </p:cNvPr>
+          <p:cNvSpPr>
+            <a:spLocks noGrp="1"/>
+          </p:cNvSpPr>
+          <p:nvPr>
+            <p:ph idx="13" sz="quarter" type="body"/>
           </p:nvPr>
         </p:nvSpPr>
         <p:spPr/>
@@ -4291,56 +4298,46 @@
           <a:bodyPr/>
           <a:lstStyle/>
           <a:p>
-            <a:pPr lvl="0"/>
-            <a:r>
-              <a:rPr/>
-              <a:t>Data quality and robustness</a:t>
-            </a:r>
-          </a:p>
-          <a:p>
-            <a:pPr lvl="0"/>
-            <a:r>
-              <a:rPr/>
-              <a:t>No below site-level analysis</a:t>
-            </a:r>
-          </a:p>
-          <a:p>
-            <a:pPr lvl="0"/>
-            <a:r>
-              <a:rPr/>
-              <a:t>Sensitivity/Specificity of some of the proxy measures</a:t>
-            </a:r>
-          </a:p>
-          <a:p>
-            <a:pPr lvl="0"/>
-            <a:r>
-              <a:rPr/>
-              <a:t>Dose-response effects are not possible to ascertain (e.g. an x% change in SBR leads to a y% change in impact A)</a:t>
-            </a:r>
-          </a:p>
-          <a:p>
-            <a:pPr lvl="0"/>
-            <a:r>
-              <a:rPr/>
-              <a:t>Covid 19 bias in some of the pre and post trends</a:t>
-            </a:r>
-          </a:p>
-          <a:p>
-            <a:pPr lvl="0"/>
-            <a:r>
-              <a:rPr/>
-              <a:t>Small pool of control sites and lack of comparability (specialist sites)</a:t>
-            </a:r>
-          </a:p>
-          <a:p>
-            <a:pPr lvl="0"/>
-            <a:r>
-              <a:rPr/>
-              <a:t>Model fit and large credible intervals</a:t>
-            </a:r>
-          </a:p>
-        </p:txBody>
-      </p:sp>
+            <a:pPr lvl="0" indent="0" marL="0">
+              <a:buNone/>
+            </a:pPr>
+            <a:r>
+              <a:rPr/>
+              <a:t>The table across demonstrates the range of impacts across all new hospital sites for each impact measure as well as point estimates for pooled general acute sites.</a:t>
+            </a:r>
+          </a:p>
+        </p:txBody>
+      </p:sp>
+      <p:pic>
+        <p:nvPicPr>
+          <p:cNvPr descr="images/impact_range.jpeg" id="0" name="Picture 1"/>
+          <p:cNvPicPr>
+            <a:picLocks noGrp="1" noChangeAspect="1"/>
+          </p:cNvPicPr>
+          <p:nvPr/>
+        </p:nvPicPr>
+        <p:blipFill>
+          <a:blip r:embed="rId2"/>
+          <a:stretch>
+            <a:fillRect/>
+          </a:stretch>
+        </p:blipFill>
+        <p:spPr bwMode="auto">
+          <a:xfrm>
+            <a:off x="4127500" y="2374900"/>
+            <a:ext cx="7010400" cy="2616200"/>
+          </a:xfrm>
+          <a:prstGeom prst="rect">
+            <a:avLst/>
+          </a:prstGeom>
+          <a:noFill/>
+          <a:ln w="9525">
+            <a:noFill/>
+            <a:headEnd/>
+            <a:tailEnd/>
+          </a:ln>
+        </p:spPr>
+      </p:pic>
     </p:spTree>
   </p:cSld>
 </p:sld>
@@ -4388,7 +4385,7 @@
             </a:pPr>
             <a:r>
               <a:rPr/>
-              <a:t>2.6 Recommendations</a:t>
+              <a:t>2.5 Limitations</a:t>
             </a:r>
           </a:p>
         </p:txBody>
@@ -4411,56 +4408,49 @@
             <a:pPr lvl="0"/>
             <a:r>
               <a:rPr/>
-              <a:t>Exercise caution when accounting for these impacts in business planning – use a range and suitable comparator.</a:t>
+              <a:t>Data quality and consistency issues over time</a:t>
             </a:r>
           </a:p>
           <a:p>
             <a:pPr lvl="0"/>
             <a:r>
               <a:rPr/>
-              <a:t>Develop an evaluation framework from (some of) these measures, process indicators and wider evidence (logic model).</a:t>
+              <a:t>No below site-level analysis possible (e.g. treatment specialty/service)</a:t>
             </a:r>
           </a:p>
           <a:p>
             <a:pPr lvl="0"/>
             <a:r>
               <a:rPr/>
-              <a:t>Include qualitative survey measures for patients and staff (free text for thematic analysis).</a:t>
+              <a:t>Poor sensitivity/specificity of some of the proxy measures</a:t>
             </a:r>
           </a:p>
           <a:p>
             <a:pPr lvl="0"/>
             <a:r>
               <a:rPr/>
-              <a:t>Capture information on design, systemic and cultural factors that may also have bearing on these impacts.</a:t>
+              <a:t>Dose-response effects are not possible to ascertain (e.g. an x% change in SBR leads to a y% change in impact A)</a:t>
             </a:r>
           </a:p>
           <a:p>
             <a:pPr lvl="0"/>
             <a:r>
               <a:rPr/>
-              <a:t>Start collecting data well before the change in bed provision and at least monthly!</a:t>
+              <a:t>Covid 19 bias in some of the pre and post trends</a:t>
             </a:r>
           </a:p>
           <a:p>
             <a:pPr lvl="0"/>
             <a:r>
               <a:rPr/>
-              <a:t>System dynamics modelling would aid understanding of multi-factorial productivity impacts (i.e. waiting lists, length of stay and bed occupancy).</a:t>
+              <a:t>Small pool of control sites and lack of comparability (specialist sites)</a:t>
             </a:r>
           </a:p>
           <a:p>
             <a:pPr lvl="0"/>
             <a:r>
               <a:rPr/>
-              <a:t>Undertake length of stay sub-group analysis i.e. by clinical and patient groups.</a:t>
-            </a:r>
-          </a:p>
-          <a:p>
-            <a:pPr lvl="0"/>
-            <a:r>
-              <a:rPr/>
-              <a:t>Mitigation strategies for staff well-being and retention.</a:t>
+              <a:t>Model fit and large credible intervals</a:t>
             </a:r>
           </a:p>
         </p:txBody>
@@ -4494,13 +4484,13 @@
             <a:spLocks noGrp="1"/>
           </p:cNvSpPr>
           <p:nvPr>
-            <p:ph hasCustomPrompt="1" type="ctrTitle"/>
+            <p:ph hasCustomPrompt="1" type="title"/>
           </p:nvPr>
         </p:nvSpPr>
         <p:spPr>
           <a:xfrm>
-            <a:off x="457199" y="4665306"/>
-            <a:ext cx="7772400" cy="1308413"/>
+            <a:off x="909829" y="403765"/>
+            <a:ext cx="8434196" cy="976056"/>
           </a:xfrm>
         </p:spPr>
         <p:txBody>
@@ -4512,7 +4502,79 @@
             </a:pPr>
             <a:r>
               <a:rPr/>
-              <a:t>3. The impact framework</a:t>
+              <a:t>2.6 Recommendations</a:t>
+            </a:r>
+          </a:p>
+        </p:txBody>
+      </p:sp>
+      <p:sp>
+        <p:nvSpPr>
+          <p:cNvPr id="3" name="Content Placeholder 2"/>
+          <p:cNvSpPr>
+            <a:spLocks noGrp="1"/>
+          </p:cNvSpPr>
+          <p:nvPr>
+            <p:ph idx="1"/>
+          </p:nvPr>
+        </p:nvSpPr>
+        <p:spPr/>
+        <p:txBody>
+          <a:bodyPr/>
+          <a:lstStyle/>
+          <a:p>
+            <a:pPr lvl="0"/>
+            <a:r>
+              <a:rPr/>
+              <a:t>Exercise caution when accounting for these impacts in business planning - use a range and suitable benchmark.</a:t>
+            </a:r>
+          </a:p>
+          <a:p>
+            <a:pPr lvl="0"/>
+            <a:r>
+              <a:rPr/>
+              <a:t>Develop an evaluation framework from (some of) these measures, process indicators and wider evidence (logic model).</a:t>
+            </a:r>
+          </a:p>
+          <a:p>
+            <a:pPr lvl="0"/>
+            <a:r>
+              <a:rPr/>
+              <a:t>Include qualitative survey measures for patients and staff (free text for thematic analysis).</a:t>
+            </a:r>
+          </a:p>
+          <a:p>
+            <a:pPr lvl="0"/>
+            <a:r>
+              <a:rPr/>
+              <a:t>Capture information on design, systemic and cultural factors that may also have bearing on these impacts.</a:t>
+            </a:r>
+          </a:p>
+          <a:p>
+            <a:pPr lvl="0"/>
+            <a:r>
+              <a:rPr/>
+              <a:t>Start collecting data well before the change in bed provision and at least monthly!</a:t>
+            </a:r>
+          </a:p>
+          <a:p>
+            <a:pPr lvl="0"/>
+            <a:r>
+              <a:rPr/>
+              <a:t>System dynamics modelling would aid understanding of multi-factorial productivity impacts (i.e. waiting lists, length of stay and bed occupancy).</a:t>
+            </a:r>
+          </a:p>
+          <a:p>
+            <a:pPr lvl="0"/>
+            <a:r>
+              <a:rPr/>
+              <a:t>Undertake length of stay sub-group analysis i.e. by clinical and patient groups.</a:t>
+            </a:r>
+          </a:p>
+          <a:p>
+            <a:pPr lvl="0"/>
+            <a:r>
+              <a:rPr/>
+              <a:t>Mitigation strategies for staff well-being and retention.</a:t>
             </a:r>
           </a:p>
         </p:txBody>
@@ -4546,13 +4608,13 @@
             <a:spLocks noGrp="1"/>
           </p:cNvSpPr>
           <p:nvPr>
-            <p:ph hasCustomPrompt="1" type="title"/>
+            <p:ph hasCustomPrompt="1" type="ctrTitle"/>
           </p:nvPr>
         </p:nvSpPr>
         <p:spPr>
           <a:xfrm>
-            <a:off x="909829" y="403765"/>
-            <a:ext cx="8434196" cy="976056"/>
+            <a:off x="457199" y="4665306"/>
+            <a:ext cx="7772400" cy="1308413"/>
           </a:xfrm>
         </p:spPr>
         <p:txBody>
@@ -4564,41 +4626,11 @@
             </a:pPr>
             <a:r>
               <a:rPr/>
-              <a:t>3.1 Overview</a:t>
-            </a:r>
-          </a:p>
-        </p:txBody>
-      </p:sp>
-      <p:pic>
-        <p:nvPicPr>
-          <p:cNvPr descr="images/indicators.jpeg" id="0" name="Picture 1"/>
-          <p:cNvPicPr>
-            <a:picLocks noGrp="1" noChangeAspect="1"/>
-          </p:cNvPicPr>
-          <p:nvPr/>
-        </p:nvPicPr>
-        <p:blipFill>
-          <a:blip r:embed="rId2"/>
-          <a:stretch>
-            <a:fillRect/>
-          </a:stretch>
-        </p:blipFill>
-        <p:spPr bwMode="auto">
-          <a:xfrm>
-            <a:off x="901700" y="2032000"/>
-            <a:ext cx="10414000" cy="3454400"/>
-          </a:xfrm>
-          <a:prstGeom prst="rect">
-            <a:avLst/>
-          </a:prstGeom>
-          <a:noFill/>
-          <a:ln w="9525">
-            <a:noFill/>
-            <a:headEnd/>
-            <a:tailEnd/>
-          </a:ln>
-        </p:spPr>
-      </p:pic>
+              <a:t>3. The impact framework</a:t>
+            </a:r>
+          </a:p>
+        </p:txBody>
+      </p:sp>
     </p:spTree>
   </p:cSld>
 </p:sld>
@@ -4646,14 +4678,14 @@
             </a:pPr>
             <a:r>
               <a:rPr/>
-              <a:t>3.2 Indicator availability and time of SBR changes by site</a:t>
+              <a:t>3.1 Overview</a:t>
             </a:r>
           </a:p>
         </p:txBody>
       </p:sp>
       <p:pic>
         <p:nvPicPr>
-          <p:cNvPr descr="NHP_SBR-impacts_2024_summaryfinal_files/figure-pptx/ind_timeline-1.png" id="0" name="Picture 1"/>
+          <p:cNvPr descr="images/indicators.jpeg" id="0" name="Picture 1"/>
           <p:cNvPicPr>
             <a:picLocks noGrp="1" noChangeAspect="1"/>
           </p:cNvPicPr>
@@ -4667,8 +4699,8 @@
         </p:blipFill>
         <p:spPr bwMode="auto">
           <a:xfrm>
-            <a:off x="2032000" y="1727200"/>
-            <a:ext cx="8153400" cy="4076700"/>
+            <a:off x="901700" y="2032000"/>
+            <a:ext cx="10414000" cy="3454400"/>
           </a:xfrm>
           <a:prstGeom prst="rect">
             <a:avLst/>
@@ -4710,13 +4742,13 @@
             <a:spLocks noGrp="1"/>
           </p:cNvSpPr>
           <p:nvPr>
-            <p:ph hasCustomPrompt="1" type="ctrTitle"/>
+            <p:ph hasCustomPrompt="1" type="title"/>
           </p:nvPr>
         </p:nvSpPr>
         <p:spPr>
           <a:xfrm>
-            <a:off x="457199" y="4665306"/>
-            <a:ext cx="7772400" cy="1308413"/>
+            <a:off x="909829" y="403765"/>
+            <a:ext cx="8434196" cy="976056"/>
           </a:xfrm>
         </p:spPr>
         <p:txBody>
@@ -4728,11 +4760,41 @@
             </a:pPr>
             <a:r>
               <a:rPr/>
-              <a:t>4. The hospitals</a:t>
-            </a:r>
-          </a:p>
-        </p:txBody>
-      </p:sp>
+              <a:t>3.2 Indicator availability and time of SBR changes by site</a:t>
+            </a:r>
+          </a:p>
+        </p:txBody>
+      </p:sp>
+      <p:pic>
+        <p:nvPicPr>
+          <p:cNvPr descr="NHP_SBR-impacts_2024_summaryfinal_files/figure-pptx/ind_timeline-1.png" id="0" name="Picture 1"/>
+          <p:cNvPicPr>
+            <a:picLocks noGrp="1" noChangeAspect="1"/>
+          </p:cNvPicPr>
+          <p:nvPr/>
+        </p:nvPicPr>
+        <p:blipFill>
+          <a:blip r:embed="rId2"/>
+          <a:stretch>
+            <a:fillRect/>
+          </a:stretch>
+        </p:blipFill>
+        <p:spPr bwMode="auto">
+          <a:xfrm>
+            <a:off x="2032000" y="1727200"/>
+            <a:ext cx="8153400" cy="4076700"/>
+          </a:xfrm>
+          <a:prstGeom prst="rect">
+            <a:avLst/>
+          </a:prstGeom>
+          <a:noFill/>
+          <a:ln w="9525">
+            <a:noFill/>
+            <a:headEnd/>
+            <a:tailEnd/>
+          </a:ln>
+        </p:spPr>
+      </p:pic>
     </p:spTree>
   </p:cSld>
 </p:sld>
@@ -4762,13 +4824,13 @@
             <a:spLocks noGrp="1"/>
           </p:cNvSpPr>
           <p:nvPr>
-            <p:ph hasCustomPrompt="1" type="title"/>
+            <p:ph hasCustomPrompt="1" type="ctrTitle"/>
           </p:nvPr>
         </p:nvSpPr>
         <p:spPr>
           <a:xfrm>
-            <a:off x="909829" y="438150"/>
-            <a:ext cx="8434196" cy="914400"/>
+            <a:off x="457199" y="4665306"/>
+            <a:ext cx="7772400" cy="1308413"/>
           </a:xfrm>
         </p:spPr>
         <p:txBody>
@@ -4780,112 +4842,11 @@
             </a:pPr>
             <a:r>
               <a:rPr/>
-              <a:t>4.1 Seven natural experiments</a:t>
-            </a:r>
-          </a:p>
-        </p:txBody>
-      </p:sp>
-      <p:sp>
-        <p:nvSpPr>
-          <p:cNvPr id="7" name="Text Placeholder 6">
-            <a:extLst>
-              <a:ext uri="{FF2B5EF4-FFF2-40B4-BE49-F238E27FC236}">
-                <a16:creationId xmlns:a16="http://schemas.microsoft.com/office/drawing/2014/main" id="{DE622849-4EA7-24AE-DD96-E693EAA81594}"/>
-              </a:ext>
-            </a:extLst>
-          </p:cNvPr>
-          <p:cNvSpPr>
-            <a:spLocks noGrp="1"/>
-          </p:cNvSpPr>
-          <p:nvPr>
-            <p:ph idx="13" sz="quarter" type="body"/>
-          </p:nvPr>
-        </p:nvSpPr>
-        <p:spPr/>
-        <p:txBody>
-          <a:bodyPr/>
-          <a:lstStyle/>
-          <a:p>
-            <a:pPr lvl="0"/>
-            <a:r>
-              <a:rPr/>
-              <a:t>Royal Liverpool (Oct 2022)</a:t>
-            </a:r>
-          </a:p>
-          <a:p>
-            <a:pPr lvl="0"/>
-            <a:r>
-              <a:rPr/>
-              <a:t>Clatterbridge Cancer Centre (June 2020)</a:t>
-            </a:r>
-          </a:p>
-          <a:p>
-            <a:pPr lvl="0"/>
-            <a:r>
-              <a:rPr/>
-              <a:t>Royal Papworth Hospital (May 2019)</a:t>
-            </a:r>
-          </a:p>
-          <a:p>
-            <a:pPr lvl="0"/>
-            <a:r>
-              <a:rPr/>
-              <a:t>Chase Farm Hospital (Sept 2018)</a:t>
-            </a:r>
-          </a:p>
-          <a:p>
-            <a:pPr lvl="0"/>
-            <a:r>
-              <a:rPr/>
-              <a:t>Southmead Hospital (May 2014)</a:t>
-            </a:r>
-          </a:p>
-          <a:p>
-            <a:pPr lvl="0"/>
-            <a:r>
-              <a:rPr/>
-              <a:t>Tunbridge Wells (Jan/Sept 2011)</a:t>
-            </a:r>
-          </a:p>
-          <a:p>
-            <a:pPr lvl="0"/>
-            <a:r>
-              <a:rPr/>
-              <a:t>Peterborough Hospital (Nov 2010)</a:t>
-            </a:r>
-          </a:p>
-        </p:txBody>
-      </p:sp>
-      <p:pic>
-        <p:nvPicPr>
-          <p:cNvPr descr="images/hospitals_map.png" id="0" name="Picture 1"/>
-          <p:cNvPicPr>
-            <a:picLocks noGrp="1" noChangeAspect="1"/>
-          </p:cNvPicPr>
-          <p:nvPr/>
-        </p:nvPicPr>
-        <p:blipFill>
-          <a:blip r:embed="rId2"/>
-          <a:stretch>
-            <a:fillRect/>
-          </a:stretch>
-        </p:blipFill>
-        <p:spPr bwMode="auto">
-          <a:xfrm>
-            <a:off x="4406900" y="1549400"/>
-            <a:ext cx="6438900" cy="4254500"/>
-          </a:xfrm>
-          <a:prstGeom prst="rect">
-            <a:avLst/>
-          </a:prstGeom>
-          <a:noFill/>
-          <a:ln w="9525">
-            <a:noFill/>
-            <a:headEnd/>
-            <a:tailEnd/>
-          </a:ln>
-        </p:spPr>
-      </p:pic>
+              <a:t>4. The hospitals</a:t>
+            </a:r>
+          </a:p>
+        </p:txBody>
+      </p:sp>
     </p:spTree>
   </p:cSld>
 </p:sld>
@@ -4920,8 +4881,8 @@
         </p:nvSpPr>
         <p:spPr>
           <a:xfrm>
-            <a:off x="909829" y="403765"/>
-            <a:ext cx="8434196" cy="976056"/>
+            <a:off x="909829" y="438150"/>
+            <a:ext cx="8434196" cy="914400"/>
           </a:xfrm>
         </p:spPr>
         <p:txBody>
@@ -4933,19 +4894,25 @@
             </a:pPr>
             <a:r>
               <a:rPr/>
-              <a:t>4.2 Heterogeneity</a:t>
-            </a:r>
-          </a:p>
-        </p:txBody>
-      </p:sp>
-      <p:sp>
-        <p:nvSpPr>
-          <p:cNvPr id="3" name="Content Placeholder 2"/>
-          <p:cNvSpPr>
-            <a:spLocks noGrp="1"/>
-          </p:cNvSpPr>
-          <p:nvPr>
-            <p:ph idx="1"/>
+              <a:t>4.1 Seven natural experiments</a:t>
+            </a:r>
+          </a:p>
+        </p:txBody>
+      </p:sp>
+      <p:sp>
+        <p:nvSpPr>
+          <p:cNvPr id="7" name="Text Placeholder 6">
+            <a:extLst>
+              <a:ext uri="{FF2B5EF4-FFF2-40B4-BE49-F238E27FC236}">
+                <a16:creationId xmlns:a16="http://schemas.microsoft.com/office/drawing/2014/main" id="{DE622849-4EA7-24AE-DD96-E693EAA81594}"/>
+              </a:ext>
+            </a:extLst>
+          </p:cNvPr>
+          <p:cNvSpPr>
+            <a:spLocks noGrp="1"/>
+          </p:cNvSpPr>
+          <p:nvPr>
+            <p:ph idx="13" sz="quarter" type="body"/>
           </p:nvPr>
         </p:nvSpPr>
         <p:spPr/>
@@ -4953,25 +4920,86 @@
           <a:bodyPr/>
           <a:lstStyle/>
           <a:p>
-            <a:pPr lvl="0" indent="0" marL="0">
-              <a:buNone/>
-            </a:pPr>
-            <a:r>
-              <a:rPr/>
-              <a:t>No hospital site is the same as another. This is no more true than for our 7 natural experiments. The sites are a mixture of general acute hospitals and specialist ones. They vary in size and function and there are many possible confounding factors in the input-output logic model for our impacts that we can not identify nor account for.</a:t>
-            </a:r>
-          </a:p>
-          <a:p>
-            <a:pPr lvl="0" indent="0" marL="0">
-              <a:buNone/>
-            </a:pPr>
-            <a:r>
-              <a:rPr/>
-              <a:t>In aggregating some of the findings in this analysis, we have grouped the general acute sites together for indicative purposes. However; the nature of those hospital systems and the social and cultural circumstance should be considerations when both interpreting our findings and also in considering single-bed provision within new hospital developments.</a:t>
-            </a:r>
-          </a:p>
-        </p:txBody>
-      </p:sp>
+            <a:pPr lvl="0"/>
+            <a:r>
+              <a:rPr/>
+              <a:t>Royal Liverpool (Oct 2022)</a:t>
+            </a:r>
+          </a:p>
+          <a:p>
+            <a:pPr lvl="0"/>
+            <a:r>
+              <a:rPr/>
+              <a:t>Clatterbridge Cancer Centre (June 2020)</a:t>
+            </a:r>
+          </a:p>
+          <a:p>
+            <a:pPr lvl="0"/>
+            <a:r>
+              <a:rPr/>
+              <a:t>Royal Papworth Hospital (May 2019)</a:t>
+            </a:r>
+          </a:p>
+          <a:p>
+            <a:pPr lvl="0"/>
+            <a:r>
+              <a:rPr/>
+              <a:t>Chase Farm Hospital (Sept 2018)</a:t>
+            </a:r>
+          </a:p>
+          <a:p>
+            <a:pPr lvl="0"/>
+            <a:r>
+              <a:rPr/>
+              <a:t>Southmead Hospital (May 2014)</a:t>
+            </a:r>
+          </a:p>
+          <a:p>
+            <a:pPr lvl="0"/>
+            <a:r>
+              <a:rPr/>
+              <a:t>Tunbridge Wells (Jan/Sept 2011)</a:t>
+            </a:r>
+          </a:p>
+          <a:p>
+            <a:pPr lvl="0"/>
+            <a:r>
+              <a:rPr/>
+              <a:t>Peterborough Hospital (Nov 2010)</a:t>
+            </a:r>
+          </a:p>
+        </p:txBody>
+      </p:sp>
+      <p:pic>
+        <p:nvPicPr>
+          <p:cNvPr descr="images/hospitals_map.png" id="0" name="Picture 1"/>
+          <p:cNvPicPr>
+            <a:picLocks noGrp="1" noChangeAspect="1"/>
+          </p:cNvPicPr>
+          <p:nvPr/>
+        </p:nvPicPr>
+        <p:blipFill>
+          <a:blip r:embed="rId2"/>
+          <a:stretch>
+            <a:fillRect/>
+          </a:stretch>
+        </p:blipFill>
+        <p:spPr bwMode="auto">
+          <a:xfrm>
+            <a:off x="4406900" y="1549400"/>
+            <a:ext cx="6438900" cy="4254500"/>
+          </a:xfrm>
+          <a:prstGeom prst="rect">
+            <a:avLst/>
+          </a:prstGeom>
+          <a:noFill/>
+          <a:ln w="9525">
+            <a:noFill/>
+            <a:headEnd/>
+            <a:tailEnd/>
+          </a:ln>
+        </p:spPr>
+      </p:pic>
     </p:spTree>
   </p:cSld>
 </p:sld>
@@ -5001,13 +5029,13 @@
             <a:spLocks noGrp="1"/>
           </p:cNvSpPr>
           <p:nvPr>
-            <p:ph hasCustomPrompt="1" type="ctrTitle"/>
+            <p:ph hasCustomPrompt="1" type="title"/>
           </p:nvPr>
         </p:nvSpPr>
         <p:spPr>
           <a:xfrm>
-            <a:off x="457199" y="4665306"/>
-            <a:ext cx="7772400" cy="1308413"/>
+            <a:off x="909829" y="403765"/>
+            <a:ext cx="8434196" cy="976056"/>
           </a:xfrm>
         </p:spPr>
         <p:txBody>
@@ -5019,7 +5047,41 @@
             </a:pPr>
             <a:r>
               <a:rPr/>
-              <a:t>5. Summary of methods</a:t>
+              <a:t>4.2 Heterogeneity</a:t>
+            </a:r>
+          </a:p>
+        </p:txBody>
+      </p:sp>
+      <p:sp>
+        <p:nvSpPr>
+          <p:cNvPr id="3" name="Content Placeholder 2"/>
+          <p:cNvSpPr>
+            <a:spLocks noGrp="1"/>
+          </p:cNvSpPr>
+          <p:nvPr>
+            <p:ph idx="1"/>
+          </p:nvPr>
+        </p:nvSpPr>
+        <p:spPr/>
+        <p:txBody>
+          <a:bodyPr/>
+          <a:lstStyle/>
+          <a:p>
+            <a:pPr lvl="0" indent="0" marL="0">
+              <a:buNone/>
+            </a:pPr>
+            <a:r>
+              <a:rPr/>
+              <a:t>No hospital site is the same as another. This is no more true than for our 7 natural experiments. The sites are a mixture of general acute hospitals and specialist ones. They vary in size and function and there are many possible confounding factors in the input-output logic model for our impacts that we can not identify nor account for.</a:t>
+            </a:r>
+          </a:p>
+          <a:p>
+            <a:pPr lvl="0" indent="0" marL="0">
+              <a:buNone/>
+            </a:pPr>
+            <a:r>
+              <a:rPr/>
+              <a:t>In aggregating some of the findings in this analysis, we have grouped the general acute sites together for indicative purposes. However; the nature of those hospital systems and the social and cultural circumstance should be considerations when both interpreting our findings and also in considering single-bed provision within new hospital developments.</a:t>
             </a:r>
           </a:p>
         </p:txBody>
@@ -5053,13 +5115,13 @@
             <a:spLocks noGrp="1"/>
           </p:cNvSpPr>
           <p:nvPr>
-            <p:ph type="title"/>
+            <p:ph hasCustomPrompt="1" type="ctrTitle"/>
           </p:nvPr>
         </p:nvSpPr>
         <p:spPr>
           <a:xfrm>
-            <a:off x="919352" y="419100"/>
-            <a:ext cx="9720072" cy="933450"/>
+            <a:off x="457199" y="4665306"/>
+            <a:ext cx="7772400" cy="1308413"/>
           </a:xfrm>
         </p:spPr>
         <p:txBody>
@@ -5071,120 +5133,11 @@
             </a:pPr>
             <a:r>
               <a:rPr/>
-              <a:t>5.1 Selecting control sites</a:t>
-            </a:r>
-          </a:p>
-        </p:txBody>
-      </p:sp>
-      <p:sp>
-        <p:nvSpPr>
-          <p:cNvPr id="3" name="Content Placeholder 2">
-            <a:extLst>
-              <a:ext uri="{FF2B5EF4-FFF2-40B4-BE49-F238E27FC236}">
-                <a16:creationId xmlns:a16="http://schemas.microsoft.com/office/drawing/2014/main" id="{D2592819-5C80-B996-F823-F8B9F9EAD6C9}"/>
-              </a:ext>
-            </a:extLst>
-          </p:cNvPr>
-          <p:cNvSpPr>
-            <a:spLocks noGrp="1"/>
-          </p:cNvSpPr>
-          <p:nvPr>
-            <p:ph idx="10"/>
-          </p:nvPr>
-        </p:nvSpPr>
-        <p:spPr/>
-        <p:txBody>
-          <a:bodyPr/>
-          <a:lstStyle/>
-          <a:p>
-            <a:pPr lvl="0" indent="0" marL="0">
-              <a:buNone/>
-            </a:pPr>
-            <a:r>
-              <a:rPr/>
-              <a:t>Before including control sites into the calculation of the post-intervention counterfactual, we must ensure they’re similar to the site under study. We do this in several consecutive steps:</a:t>
-            </a:r>
-          </a:p>
-          <a:p>
-            <a:pPr lvl="0" indent="-457200" marL="457200">
-              <a:buAutoNum type="arabicPeriod"/>
-            </a:pPr>
-            <a:r>
-              <a:rPr/>
-              <a:t>Filter on similar site types e.g. General Acute, Tertiary Centre</a:t>
-            </a:r>
-          </a:p>
-          <a:p>
-            <a:pPr lvl="0" indent="-457200" marL="457200">
-              <a:buAutoNum type="arabicPeriod"/>
-            </a:pPr>
-            <a:r>
-              <a:rPr/>
-              <a:t>Exclude those with dissimilar single bed %‘s at the point of ’intervention’</a:t>
-            </a:r>
-          </a:p>
-          <a:p>
-            <a:pPr lvl="0" indent="-457200" marL="457200">
-              <a:buAutoNum type="arabicPeriod"/>
-            </a:pPr>
-            <a:r>
-              <a:rPr/>
-              <a:t>Match (on the closest 20) according to the following variables:</a:t>
-            </a:r>
-          </a:p>
-          <a:p>
-            <a:pPr lvl="0"/>
-            <a:r>
-              <a:rPr/>
-              <a:t>Hospital size (m2)</a:t>
-            </a:r>
-          </a:p>
-          <a:p>
-            <a:pPr lvl="0"/>
-            <a:r>
-              <a:rPr/>
-              <a:t>Patient case-mix (median age)</a:t>
-            </a:r>
-          </a:p>
-          <a:p>
-            <a:pPr lvl="0"/>
-            <a:r>
-              <a:rPr/>
-              <a:t>Elective:Non-elective spell ratio</a:t>
-            </a:r>
-          </a:p>
-        </p:txBody>
-      </p:sp>
-      <p:pic>
-        <p:nvPicPr>
-          <p:cNvPr descr="images/control_flowchart.png" id="0" name="Picture 1"/>
-          <p:cNvPicPr>
-            <a:picLocks noGrp="1" noChangeAspect="1"/>
-          </p:cNvPicPr>
-          <p:nvPr/>
-        </p:nvPicPr>
-        <p:blipFill>
-          <a:blip r:embed="rId2"/>
-          <a:stretch>
-            <a:fillRect/>
-          </a:stretch>
-        </p:blipFill>
-        <p:spPr bwMode="auto">
-          <a:xfrm>
-            <a:off x="6223000" y="1993900"/>
-            <a:ext cx="5041900" cy="3467100"/>
-          </a:xfrm>
-          <a:prstGeom prst="rect">
-            <a:avLst/>
-          </a:prstGeom>
-          <a:noFill/>
-          <a:ln w="9525">
-            <a:noFill/>
-            <a:headEnd/>
-            <a:tailEnd/>
-          </a:ln>
-        </p:spPr>
-      </p:pic>
+              <a:t>5. Summary of methods</a:t>
+            </a:r>
+          </a:p>
+        </p:txBody>
+      </p:sp>
     </p:spTree>
   </p:cSld>
 </p:sld>
@@ -5232,7 +5185,7 @@
             </a:pPr>
             <a:r>
               <a:rPr/>
-              <a:t>1. Headlines and Highlights</a:t>
+              <a:t>1. Executive Summary</a:t>
             </a:r>
           </a:p>
         </p:txBody>
@@ -5284,7 +5237,7 @@
             </a:pPr>
             <a:r>
               <a:rPr/>
-              <a:t>5.2 Causal Impact Analysis</a:t>
+              <a:t>5.1 Selecting control sites</a:t>
             </a:r>
           </a:p>
         </p:txBody>
@@ -5315,23 +5268,62 @@
             </a:pPr>
             <a:r>
               <a:rPr/>
-              <a:t>Causal Impact Analysis (CIA), developed by K. Broderson in 2014, explicitly uses prior trends and ‘market-matched’ control analysis to predict a future time series. The observed values for the study site are compared to this prediction to determine the direction, magnitude and significance of impacts as a result of the intervention.</a:t>
-            </a:r>
-          </a:p>
-          <a:p>
-            <a:pPr lvl="0" indent="0" marL="0">
-              <a:buNone/>
-            </a:pPr>
-            <a:r>
-              <a:rPr/>
-              <a:t>All our analysis has been performed in R software (v4.3.2+) with the following packages - CausalImpact, MarketMatching, dtw, metafor.</a:t>
+              <a:t>Before including control sites into the calculation of the post-intervention counterfactual, we must ensure they’re similar to the site under study. We do this in several consecutive steps:</a:t>
+            </a:r>
+          </a:p>
+          <a:p>
+            <a:pPr lvl="0" indent="-457200" marL="457200">
+              <a:buAutoNum type="arabicPeriod"/>
+            </a:pPr>
+            <a:r>
+              <a:rPr/>
+              <a:t>Filter on similar site types e.g. General Acute, Tertiary Centre</a:t>
+            </a:r>
+          </a:p>
+          <a:p>
+            <a:pPr lvl="0" indent="-457200" marL="457200">
+              <a:buAutoNum type="arabicPeriod"/>
+            </a:pPr>
+            <a:r>
+              <a:rPr/>
+              <a:t>Exclude those with dissimilar single bed %‘s at the point of ’intervention’</a:t>
+            </a:r>
+          </a:p>
+          <a:p>
+            <a:pPr lvl="0" indent="-457200" marL="457200">
+              <a:buAutoNum type="arabicPeriod"/>
+            </a:pPr>
+            <a:r>
+              <a:rPr/>
+              <a:t>Match (on the closest 20) according to the following variables:</a:t>
+            </a:r>
+          </a:p>
+          <a:p>
+            <a:pPr lvl="0"/>
+            <a:r>
+              <a:rPr/>
+              <a:t>Hospital size (m2)</a:t>
+            </a:r>
+          </a:p>
+          <a:p>
+            <a:pPr lvl="0"/>
+            <a:r>
+              <a:rPr/>
+              <a:t>Patient case-mix (median age)</a:t>
+            </a:r>
+          </a:p>
+          <a:p>
+            <a:pPr lvl="0"/>
+            <a:r>
+              <a:rPr/>
+              <a:t>Elective:Non-elective spell ratio</a:t>
             </a:r>
           </a:p>
         </p:txBody>
       </p:sp>
       <p:pic>
         <p:nvPicPr>
-          <p:cNvPr descr="fig:  images/cia_example.png" id="0" name="Picture 1"/>
+          <p:cNvPr descr="images/control_flowchart.png" id="0" name="Picture 1"/>
           <p:cNvPicPr>
             <a:picLocks noGrp="1" noChangeAspect="1"/>
           </p:cNvPicPr>
@@ -5345,8 +5337,8 @@
         </p:blipFill>
         <p:spPr bwMode="auto">
           <a:xfrm>
-            <a:off x="7188200" y="1612900"/>
-            <a:ext cx="3098800" cy="3721100"/>
+            <a:off x="6223000" y="1993900"/>
+            <a:ext cx="5041900" cy="3467100"/>
           </a:xfrm>
           <a:prstGeom prst="rect">
             <a:avLst/>
@@ -5359,36 +5351,6 @@
           </a:ln>
         </p:spPr>
       </p:pic>
-      <p:sp>
-        <p:nvSpPr>
-          <p:cNvPr id="1" name="TextBox 3"/>
-          <p:cNvSpPr txBox="1"/>
-          <p:nvPr/>
-        </p:nvSpPr>
-        <p:spPr>
-          <a:xfrm>
-            <a:off x="6223000" y="5334000"/>
-            <a:ext cx="5041900" cy="508000"/>
-          </a:xfrm>
-          <a:prstGeom prst="rect">
-            <a:avLst/>
-          </a:prstGeom>
-          <a:noFill/>
-        </p:spPr>
-        <p:txBody>
-          <a:bodyPr/>
-          <a:lstStyle/>
-          <a:p>
-            <a:pPr lvl="0" indent="0" marL="0" algn="ctr">
-              <a:buNone/>
-            </a:pPr>
-            <a:r>
-              <a:rPr/>
-              <a:t>Example of CIA analysis</a:t>
-            </a:r>
-          </a:p>
-        </p:txBody>
-      </p:sp>
     </p:spTree>
   </p:cSld>
 </p:sld>
@@ -5436,7 +5398,7 @@
             </a:pPr>
             <a:r>
               <a:rPr/>
-              <a:t>5.3 Aggregating impacts</a:t>
+              <a:t>5.2 Causal Impact Analysis</a:t>
             </a:r>
           </a:p>
         </p:txBody>
@@ -5467,7 +5429,7 @@
             </a:pPr>
             <a:r>
               <a:rPr/>
-              <a:t>Where for each impact measure there were 2 or more general and acute hospitals, a meta-analysis was conducted. The specialist hospital sites were excluded from this analysis as it is felt the effects at these sites may not be generalisable when considering future building of general acute hospitals.</a:t>
+              <a:t>Causal Impact Analysis (CIA), developed by K. Broderson in 2014, explicitly uses prior trends and ‘market-matched’ control analysis to predict a future time series. The observed values for the study site are compared to this prediction to determine the direction, magnitude and significance of impacts as a result of the intervention.</a:t>
             </a:r>
           </a:p>
           <a:p>
@@ -5476,14 +5438,14 @@
             </a:pPr>
             <a:r>
               <a:rPr/>
-              <a:t>A random-effects meta-analysis was conducted using the metafor R package (Viechtbauer 2024) and with the relative effects for each site weighted using the inverse variance, as used for meta-analysis of causal impact models by Schmitt et al. (Schmitt, Tull, and Atwater 2017).</a:t>
+              <a:t>All our analysis has been performed in R software (v4.3.2+) with the following packages - CausalImpact, MarketMatching, dtw, metafor.</a:t>
             </a:r>
           </a:p>
         </p:txBody>
       </p:sp>
       <p:pic>
         <p:nvPicPr>
-          <p:cNvPr descr="fig:  images/meta_example.png" id="0" name="Picture 1"/>
+          <p:cNvPr descr="fig:  images/cia_example.png" id="0" name="Picture 1"/>
           <p:cNvPicPr>
             <a:picLocks noGrp="1" noChangeAspect="1"/>
           </p:cNvPicPr>
@@ -5497,8 +5459,8 @@
         </p:blipFill>
         <p:spPr bwMode="auto">
           <a:xfrm>
-            <a:off x="6223000" y="2743200"/>
-            <a:ext cx="5041900" cy="1447800"/>
+            <a:off x="7188200" y="1612900"/>
+            <a:ext cx="3098800" cy="3721100"/>
           </a:xfrm>
           <a:prstGeom prst="rect">
             <a:avLst/>
@@ -5536,7 +5498,7 @@
             </a:pPr>
             <a:r>
               <a:rPr/>
-              <a:t>Example of meta-analysis</a:t>
+              <a:t>Example of CIA analysis</a:t>
             </a:r>
           </a:p>
         </p:txBody>
@@ -5570,13 +5532,13 @@
             <a:spLocks noGrp="1"/>
           </p:cNvSpPr>
           <p:nvPr>
-            <p:ph hasCustomPrompt="1" type="ctrTitle"/>
+            <p:ph type="title"/>
           </p:nvPr>
         </p:nvSpPr>
         <p:spPr>
           <a:xfrm>
-            <a:off x="457199" y="4665306"/>
-            <a:ext cx="7772400" cy="1308413"/>
+            <a:off x="919352" y="419100"/>
+            <a:ext cx="9720072" cy="933450"/>
           </a:xfrm>
         </p:spPr>
         <p:txBody>
@@ -5588,7 +5550,107 @@
             </a:pPr>
             <a:r>
               <a:rPr/>
-              <a:t>6. Main results - Productivity and Efficiency</a:t>
+              <a:t>5.3 Aggregating impacts</a:t>
+            </a:r>
+          </a:p>
+        </p:txBody>
+      </p:sp>
+      <p:sp>
+        <p:nvSpPr>
+          <p:cNvPr id="3" name="Content Placeholder 2">
+            <a:extLst>
+              <a:ext uri="{FF2B5EF4-FFF2-40B4-BE49-F238E27FC236}">
+                <a16:creationId xmlns:a16="http://schemas.microsoft.com/office/drawing/2014/main" id="{D2592819-5C80-B996-F823-F8B9F9EAD6C9}"/>
+              </a:ext>
+            </a:extLst>
+          </p:cNvPr>
+          <p:cNvSpPr>
+            <a:spLocks noGrp="1"/>
+          </p:cNvSpPr>
+          <p:nvPr>
+            <p:ph idx="10"/>
+          </p:nvPr>
+        </p:nvSpPr>
+        <p:spPr/>
+        <p:txBody>
+          <a:bodyPr/>
+          <a:lstStyle/>
+          <a:p>
+            <a:pPr lvl="0" indent="0" marL="0">
+              <a:buNone/>
+            </a:pPr>
+            <a:r>
+              <a:rPr/>
+              <a:t>Where for each impact measure there were 2 or more general and acute hospitals, a meta-analysis was conducted. The specialist hospital sites were excluded from this analysis as it is felt the effects at these sites may not be generalisable when considering future building of general acute hospitals.</a:t>
+            </a:r>
+          </a:p>
+          <a:p>
+            <a:pPr lvl="0" indent="0" marL="0">
+              <a:buNone/>
+            </a:pPr>
+            <a:r>
+              <a:rPr/>
+              <a:t>A random-effects meta-analysis was conducted using the metafor R package (Viechtbauer 2024) and with the relative effects for each site weighted using the inverse variance, as used for meta-analysis of causal impact models by Schmitt et al. (Schmitt, Tull, and Atwater 2017).</a:t>
+            </a:r>
+          </a:p>
+        </p:txBody>
+      </p:sp>
+      <p:pic>
+        <p:nvPicPr>
+          <p:cNvPr descr="fig:  images/meta_example.png" id="0" name="Picture 1"/>
+          <p:cNvPicPr>
+            <a:picLocks noGrp="1" noChangeAspect="1"/>
+          </p:cNvPicPr>
+          <p:nvPr/>
+        </p:nvPicPr>
+        <p:blipFill>
+          <a:blip r:embed="rId2"/>
+          <a:stretch>
+            <a:fillRect/>
+          </a:stretch>
+        </p:blipFill>
+        <p:spPr bwMode="auto">
+          <a:xfrm>
+            <a:off x="6223000" y="2743200"/>
+            <a:ext cx="5041900" cy="1447800"/>
+          </a:xfrm>
+          <a:prstGeom prst="rect">
+            <a:avLst/>
+          </a:prstGeom>
+          <a:noFill/>
+          <a:ln w="9525">
+            <a:noFill/>
+            <a:headEnd/>
+            <a:tailEnd/>
+          </a:ln>
+        </p:spPr>
+      </p:pic>
+      <p:sp>
+        <p:nvSpPr>
+          <p:cNvPr id="1" name="TextBox 3"/>
+          <p:cNvSpPr txBox="1"/>
+          <p:nvPr/>
+        </p:nvSpPr>
+        <p:spPr>
+          <a:xfrm>
+            <a:off x="6223000" y="5334000"/>
+            <a:ext cx="5041900" cy="508000"/>
+          </a:xfrm>
+          <a:prstGeom prst="rect">
+            <a:avLst/>
+          </a:prstGeom>
+          <a:noFill/>
+        </p:spPr>
+        <p:txBody>
+          <a:bodyPr/>
+          <a:lstStyle/>
+          <a:p>
+            <a:pPr lvl="0" indent="0" marL="0" algn="ctr">
+              <a:buNone/>
+            </a:pPr>
+            <a:r>
+              <a:rPr/>
+              <a:t>Example of meta-analysis</a:t>
             </a:r>
           </a:p>
         </p:txBody>
@@ -5622,13 +5684,13 @@
             <a:spLocks noGrp="1"/>
           </p:cNvSpPr>
           <p:nvPr>
-            <p:ph hasCustomPrompt="1" type="title"/>
+            <p:ph hasCustomPrompt="1" type="ctrTitle"/>
           </p:nvPr>
         </p:nvSpPr>
         <p:spPr>
           <a:xfrm>
-            <a:off x="909829" y="438150"/>
-            <a:ext cx="8434196" cy="914400"/>
+            <a:off x="457199" y="4665306"/>
+            <a:ext cx="7772400" cy="1308413"/>
           </a:xfrm>
         </p:spPr>
         <p:txBody>
@@ -5640,97 +5702,11 @@
             </a:pPr>
             <a:r>
               <a:rPr/>
-              <a:t>6.1 Length of stay</a:t>
-            </a:r>
-          </a:p>
-        </p:txBody>
-      </p:sp>
-      <p:sp>
-        <p:nvSpPr>
-          <p:cNvPr id="7" name="Text Placeholder 6">
-            <a:extLst>
-              <a:ext uri="{FF2B5EF4-FFF2-40B4-BE49-F238E27FC236}">
-                <a16:creationId xmlns:a16="http://schemas.microsoft.com/office/drawing/2014/main" id="{DE622849-4EA7-24AE-DD96-E693EAA81594}"/>
-              </a:ext>
-            </a:extLst>
-          </p:cNvPr>
-          <p:cNvSpPr>
-            <a:spLocks noGrp="1"/>
-          </p:cNvSpPr>
-          <p:nvPr>
-            <p:ph idx="13" sz="quarter" type="body"/>
-          </p:nvPr>
-        </p:nvSpPr>
-        <p:spPr/>
-        <p:txBody>
-          <a:bodyPr/>
-          <a:lstStyle/>
-          <a:p>
-            <a:pPr lvl="0" indent="0" marL="0">
-              <a:buNone/>
-            </a:pPr>
-            <a:r>
-              <a:rPr/>
-              <a:t>This </a:t>
-            </a:r>
-            <a:r>
-              <a:rPr b="1"/>
-              <a:t>monthly</a:t>
-            </a:r>
-            <a:r>
-              <a:rPr/>
-              <a:t> data at </a:t>
-            </a:r>
-            <a:r>
-              <a:rPr b="1"/>
-              <a:t>site level</a:t>
-            </a:r>
-            <a:r>
-              <a:rPr/>
-              <a:t> is derived from the Secondary Uses Service (SUS) admitted patients care spells.</a:t>
-            </a:r>
-          </a:p>
-          <a:p>
-            <a:pPr lvl="0" indent="0" marL="0">
-              <a:buNone/>
-            </a:pPr>
-            <a:r>
-              <a:rPr/>
-              <a:t>Mean length of stay (in days) significantly decreased at 3/6 sites (Southmead, Peterborough and Chase Farm), was unchanged at 2/6 sites (Royal Liverpool and Tunbridge Wells), but significantly increased at Clatterbridge.</a:t>
-            </a:r>
-          </a:p>
-        </p:txBody>
-      </p:sp>
-      <p:pic>
-        <p:nvPicPr>
-          <p:cNvPr descr="NHP_SBR-impacts_2024_summaryfinal_files/figure-pptx/cia_los-1.png" id="0" name="Picture 1"/>
-          <p:cNvPicPr>
-            <a:picLocks noGrp="1" noChangeAspect="1"/>
-          </p:cNvPicPr>
-          <p:nvPr/>
-        </p:nvPicPr>
-        <p:blipFill>
-          <a:blip r:embed="rId2"/>
-          <a:stretch>
-            <a:fillRect/>
-          </a:stretch>
-        </p:blipFill>
-        <p:spPr bwMode="auto">
-          <a:xfrm>
-            <a:off x="4127500" y="1930400"/>
-            <a:ext cx="7010400" cy="3505200"/>
-          </a:xfrm>
-          <a:prstGeom prst="rect">
-            <a:avLst/>
-          </a:prstGeom>
-          <a:noFill/>
-          <a:ln w="9525">
-            <a:noFill/>
-            <a:headEnd/>
-            <a:tailEnd/>
-          </a:ln>
-        </p:spPr>
-      </p:pic>
+              <a:t>6. Main results - Productivity and Efficiency</a:t>
+            </a:r>
+          </a:p>
+        </p:txBody>
+      </p:sp>
     </p:spTree>
   </p:cSld>
 </p:sld>
@@ -5778,7 +5754,7 @@
             </a:pPr>
             <a:r>
               <a:rPr/>
-              <a:t>6.2 Waiting times</a:t>
+              <a:t>6.1 Length of stay</a:t>
             </a:r>
           </a:p>
         </p:txBody>
@@ -5821,11 +5797,11 @@
             </a:r>
             <a:r>
               <a:rPr b="1"/>
-              <a:t>provider level</a:t>
-            </a:r>
-            <a:r>
-              <a:rPr/>
-              <a:t> is from published RTT waiting times dataset (via UDAL).</a:t>
+              <a:t>site level</a:t>
+            </a:r>
+            <a:r>
+              <a:rPr/>
+              <a:t> is derived from the Secondary Uses Service (SUS) admitted patients care spells.</a:t>
             </a:r>
           </a:p>
           <a:p>
@@ -5834,14 +5810,14 @@
             </a:pPr>
             <a:r>
               <a:rPr/>
-              <a:t>The median referral to treatment waiting time (in weeks) significantly decreased at 2/5 sites (Royal Liverpool and Peterborough) and was unchanged at 2/5 sites (Papworth and Clatterbridge) and increased at Tunbridge Wells.</a:t>
+              <a:t>Mean length of stay (in days) significantly decreased at 3/6 sites (Southmead, Peterborough and Chase Farm), was unchanged at 2/6 sites (Royal Liverpool and Tunbridge Wells), but significantly increased at Clatterbridge.</a:t>
             </a:r>
           </a:p>
         </p:txBody>
       </p:sp>
       <p:pic>
         <p:nvPicPr>
-          <p:cNvPr descr="NHP_SBR-impacts_2024_summaryfinal_files/figure-pptx/cia_wait-1.png" id="0" name="Picture 1"/>
+          <p:cNvPr descr="NHP_SBR-impacts_2024_summaryfinal_files/figure-pptx/cia_los-1.png" id="0" name="Picture 1"/>
           <p:cNvPicPr>
             <a:picLocks noGrp="1" noChangeAspect="1"/>
           </p:cNvPicPr>
@@ -5916,7 +5892,7 @@
             </a:pPr>
             <a:r>
               <a:rPr/>
-              <a:t>6.3 Bed Occupancy</a:t>
+              <a:t>6.2 Waiting times</a:t>
             </a:r>
           </a:p>
         </p:txBody>
@@ -5951,7 +5927,7 @@
             </a:r>
             <a:r>
               <a:rPr b="1"/>
-              <a:t>quarterly</a:t>
+              <a:t>monthly</a:t>
             </a:r>
             <a:r>
               <a:rPr/>
@@ -5963,7 +5939,7 @@
             </a:r>
             <a:r>
               <a:rPr/>
-              <a:t> is from published KH03 bed returns (via UDAL).</a:t>
+              <a:t> is from published RTT waiting times dataset (via UDAL).</a:t>
             </a:r>
           </a:p>
           <a:p>
@@ -5972,14 +5948,14 @@
             </a:pPr>
             <a:r>
               <a:rPr/>
-              <a:t>Bed occupancy is measured quarterly and is only available at a Provider level. The percentage of available beds occupied significantly increased at 2/4 sites (Clatterbridge and Southmead) and was unchanged at 2/4 (Royal Liverpool and and Chase Farm).</a:t>
+              <a:t>The median referral to treatment waiting time (in weeks) significantly decreased at 2/5 sites (Royal Liverpool and Peterborough) and was unchanged at 2/5 sites (Papworth and Clatterbridge) and increased at Tunbridge Wells.</a:t>
             </a:r>
           </a:p>
         </p:txBody>
       </p:sp>
       <p:pic>
         <p:nvPicPr>
-          <p:cNvPr descr="NHP_SBR-impacts_2024_summaryfinal_files/figure-pptx/cia_bedocc-1.png" id="0" name="Picture 1"/>
+          <p:cNvPr descr="NHP_SBR-impacts_2024_summaryfinal_files/figure-pptx/cia_wait-1.png" id="0" name="Picture 1"/>
           <p:cNvPicPr>
             <a:picLocks noGrp="1" noChangeAspect="1"/>
           </p:cNvPicPr>
@@ -6054,7 +6030,7 @@
             </a:pPr>
             <a:r>
               <a:rPr/>
-              <a:t>6.4 Emergency readmissions</a:t>
+              <a:t>6.3 Bed Occupancy</a:t>
             </a:r>
           </a:p>
         </p:txBody>
@@ -6089,7 +6065,7 @@
             </a:r>
             <a:r>
               <a:rPr b="1"/>
-              <a:t>monthly</a:t>
+              <a:t>quarterly</a:t>
             </a:r>
             <a:r>
               <a:rPr/>
@@ -6097,11 +6073,11 @@
             </a:r>
             <a:r>
               <a:rPr b="1"/>
-              <a:t>site level</a:t>
-            </a:r>
-            <a:r>
-              <a:rPr/>
-              <a:t> is derived from SUS admitted patient care records.</a:t>
+              <a:t>provider level</a:t>
+            </a:r>
+            <a:r>
+              <a:rPr/>
+              <a:t> is from published KH03 bed returns (via UDAL).</a:t>
             </a:r>
           </a:p>
           <a:p>
@@ -6110,14 +6086,14 @@
             </a:pPr>
             <a:r>
               <a:rPr/>
-              <a:t>The percentage of admissions that are emergency readmissions &lt; 30 days of discharge significantly decreased at 3/7 sites (Tunbridge Wells, Peterborough and Clatterbridge) and was unchanged at the remaining 4/7 sites.</a:t>
+              <a:t>Bed occupancy is measured quarterly and is only available at a Provider level. The percentage of available beds occupied significantly increased at 2/4 sites (Clatterbridge and Southmead) and was unchanged at 2/4 (Royal Liverpool and and Chase Farm).</a:t>
             </a:r>
           </a:p>
         </p:txBody>
       </p:sp>
       <p:pic>
         <p:nvPicPr>
-          <p:cNvPr descr="NHP_SBR-impacts_2024_summaryfinal_files/figure-pptx/cia_emergreadm-1.png" id="0" name="Picture 1"/>
+          <p:cNvPr descr="NHP_SBR-impacts_2024_summaryfinal_files/figure-pptx/cia_bedocc-1.png" id="0" name="Picture 1"/>
           <p:cNvPicPr>
             <a:picLocks noGrp="1" noChangeAspect="1"/>
           </p:cNvPicPr>
@@ -6192,7 +6168,7 @@
             </a:pPr>
             <a:r>
               <a:rPr/>
-              <a:t>6.5 Cleaning costs</a:t>
+              <a:t>6.4 Emergency readmissions</a:t>
             </a:r>
           </a:p>
         </p:txBody>
@@ -6227,7 +6203,7 @@
             </a:r>
             <a:r>
               <a:rPr b="1"/>
-              <a:t>annual</a:t>
+              <a:t>monthly</a:t>
             </a:r>
             <a:r>
               <a:rPr/>
@@ -6239,7 +6215,7 @@
             </a:r>
             <a:r>
               <a:rPr/>
-              <a:t> is taken from published Estates Return Information Collection (ERIC) datasets.</a:t>
+              <a:t> is derived from SUS admitted patient care records.</a:t>
             </a:r>
           </a:p>
           <a:p>
@@ -6248,14 +6224,14 @@
             </a:pPr>
             <a:r>
               <a:rPr/>
-              <a:t>The cleaning costs (in £) per square metre of occupied floor space significantly increased at 1/3 sites (Royal Liverpool) but decreased at 2/3 sites (Clatterbridge and Papworth).</a:t>
+              <a:t>The percentage of admissions that are emergency readmissions &lt; 30 days of discharge significantly decreased at 3/7 sites (Tunbridge Wells, Peterborough and Clatterbridge) and was unchanged at the remaining 4/7 sites.</a:t>
             </a:r>
           </a:p>
         </p:txBody>
       </p:sp>
       <p:pic>
         <p:nvPicPr>
-          <p:cNvPr descr="NHP_SBR-impacts_2024_summaryfinal_files/figure-pptx/cia_cleaning-1.png" id="0" name="Picture 1"/>
+          <p:cNvPr descr="NHP_SBR-impacts_2024_summaryfinal_files/figure-pptx/cia_emergreadm-1.png" id="0" name="Picture 1"/>
           <p:cNvPicPr>
             <a:picLocks noGrp="1" noChangeAspect="1"/>
           </p:cNvPicPr>
@@ -6312,13 +6288,13 @@
             <a:spLocks noGrp="1"/>
           </p:cNvSpPr>
           <p:nvPr>
-            <p:ph hasCustomPrompt="1" type="ctrTitle"/>
+            <p:ph hasCustomPrompt="1" type="title"/>
           </p:nvPr>
         </p:nvSpPr>
         <p:spPr>
           <a:xfrm>
-            <a:off x="457199" y="4665306"/>
-            <a:ext cx="7772400" cy="1308413"/>
+            <a:off x="909829" y="438150"/>
+            <a:ext cx="8434196" cy="914400"/>
           </a:xfrm>
         </p:spPr>
         <p:txBody>
@@ -6330,11 +6306,97 @@
             </a:pPr>
             <a:r>
               <a:rPr/>
-              <a:t>7. Main results - Health and Safety</a:t>
-            </a:r>
-          </a:p>
-        </p:txBody>
-      </p:sp>
+              <a:t>6.5 Cleaning costs</a:t>
+            </a:r>
+          </a:p>
+        </p:txBody>
+      </p:sp>
+      <p:sp>
+        <p:nvSpPr>
+          <p:cNvPr id="7" name="Text Placeholder 6">
+            <a:extLst>
+              <a:ext uri="{FF2B5EF4-FFF2-40B4-BE49-F238E27FC236}">
+                <a16:creationId xmlns:a16="http://schemas.microsoft.com/office/drawing/2014/main" id="{DE622849-4EA7-24AE-DD96-E693EAA81594}"/>
+              </a:ext>
+            </a:extLst>
+          </p:cNvPr>
+          <p:cNvSpPr>
+            <a:spLocks noGrp="1"/>
+          </p:cNvSpPr>
+          <p:nvPr>
+            <p:ph idx="13" sz="quarter" type="body"/>
+          </p:nvPr>
+        </p:nvSpPr>
+        <p:spPr/>
+        <p:txBody>
+          <a:bodyPr/>
+          <a:lstStyle/>
+          <a:p>
+            <a:pPr lvl="0" indent="0" marL="0">
+              <a:buNone/>
+            </a:pPr>
+            <a:r>
+              <a:rPr/>
+              <a:t>This </a:t>
+            </a:r>
+            <a:r>
+              <a:rPr b="1"/>
+              <a:t>annual</a:t>
+            </a:r>
+            <a:r>
+              <a:rPr/>
+              <a:t> data at </a:t>
+            </a:r>
+            <a:r>
+              <a:rPr b="1"/>
+              <a:t>site level</a:t>
+            </a:r>
+            <a:r>
+              <a:rPr/>
+              <a:t> is taken from published Estates Return Information Collection (ERIC) datasets.</a:t>
+            </a:r>
+          </a:p>
+          <a:p>
+            <a:pPr lvl="0" indent="0" marL="0">
+              <a:buNone/>
+            </a:pPr>
+            <a:r>
+              <a:rPr/>
+              <a:t>The cleaning costs (in £) per square metre of occupied floor space significantly increased at 1/3 sites (Royal Liverpool) but decreased at 2/3 sites (Clatterbridge and Papworth).</a:t>
+            </a:r>
+          </a:p>
+        </p:txBody>
+      </p:sp>
+      <p:pic>
+        <p:nvPicPr>
+          <p:cNvPr descr="NHP_SBR-impacts_2024_summaryfinal_files/figure-pptx/cia_cleaning-1.png" id="0" name="Picture 1"/>
+          <p:cNvPicPr>
+            <a:picLocks noGrp="1" noChangeAspect="1"/>
+          </p:cNvPicPr>
+          <p:nvPr/>
+        </p:nvPicPr>
+        <p:blipFill>
+          <a:blip r:embed="rId2"/>
+          <a:stretch>
+            <a:fillRect/>
+          </a:stretch>
+        </p:blipFill>
+        <p:spPr bwMode="auto">
+          <a:xfrm>
+            <a:off x="4127500" y="1930400"/>
+            <a:ext cx="7010400" cy="3505200"/>
+          </a:xfrm>
+          <a:prstGeom prst="rect">
+            <a:avLst/>
+          </a:prstGeom>
+          <a:noFill/>
+          <a:ln w="9525">
+            <a:noFill/>
+            <a:headEnd/>
+            <a:tailEnd/>
+          </a:ln>
+        </p:spPr>
+      </p:pic>
     </p:spTree>
   </p:cSld>
 </p:sld>
@@ -6364,13 +6426,13 @@
             <a:spLocks noGrp="1"/>
           </p:cNvSpPr>
           <p:nvPr>
-            <p:ph hasCustomPrompt="1" type="title"/>
+            <p:ph hasCustomPrompt="1" type="ctrTitle"/>
           </p:nvPr>
         </p:nvSpPr>
         <p:spPr>
           <a:xfrm>
-            <a:off x="909829" y="438150"/>
-            <a:ext cx="8434196" cy="914400"/>
+            <a:off x="457199" y="4665306"/>
+            <a:ext cx="7772400" cy="1308413"/>
           </a:xfrm>
         </p:spPr>
         <p:txBody>
@@ -6382,97 +6444,11 @@
             </a:pPr>
             <a:r>
               <a:rPr/>
-              <a:t>7.1 In-hospital deaths</a:t>
-            </a:r>
-          </a:p>
-        </p:txBody>
-      </p:sp>
-      <p:sp>
-        <p:nvSpPr>
-          <p:cNvPr id="7" name="Text Placeholder 6">
-            <a:extLst>
-              <a:ext uri="{FF2B5EF4-FFF2-40B4-BE49-F238E27FC236}">
-                <a16:creationId xmlns:a16="http://schemas.microsoft.com/office/drawing/2014/main" id="{DE622849-4EA7-24AE-DD96-E693EAA81594}"/>
-              </a:ext>
-            </a:extLst>
-          </p:cNvPr>
-          <p:cNvSpPr>
-            <a:spLocks noGrp="1"/>
-          </p:cNvSpPr>
-          <p:nvPr>
-            <p:ph idx="13" sz="quarter" type="body"/>
-          </p:nvPr>
-        </p:nvSpPr>
-        <p:spPr/>
-        <p:txBody>
-          <a:bodyPr/>
-          <a:lstStyle/>
-          <a:p>
-            <a:pPr lvl="0" indent="0" marL="0">
-              <a:buNone/>
-            </a:pPr>
-            <a:r>
-              <a:rPr/>
-              <a:t>This </a:t>
-            </a:r>
-            <a:r>
-              <a:rPr b="1"/>
-              <a:t>monthly</a:t>
-            </a:r>
-            <a:r>
-              <a:rPr/>
-              <a:t> data at </a:t>
-            </a:r>
-            <a:r>
-              <a:rPr b="1"/>
-              <a:t>site level</a:t>
-            </a:r>
-            <a:r>
-              <a:rPr/>
-              <a:t> is derived from SUS admitted patient care records.</a:t>
-            </a:r>
-          </a:p>
-          <a:p>
-            <a:pPr lvl="0" indent="0" marL="0">
-              <a:buNone/>
-            </a:pPr>
-            <a:r>
-              <a:rPr/>
-              <a:t>The rate of in-hospital deaths (number per 1,000 discharges) significantly decreased at 1/5 sites (Peterborough), and was unchanged at 4/5 sites (Royal Liverpool, Tunbridge Wells, Clatterbridge and Southmead).</a:t>
-            </a:r>
-          </a:p>
-        </p:txBody>
-      </p:sp>
-      <p:pic>
-        <p:nvPicPr>
-          <p:cNvPr descr="NHP_SBR-impacts_2024_summaryfinal_files/figure-pptx/cia_mort-1.png" id="0" name="Picture 1"/>
-          <p:cNvPicPr>
-            <a:picLocks noGrp="1" noChangeAspect="1"/>
-          </p:cNvPicPr>
-          <p:nvPr/>
-        </p:nvPicPr>
-        <p:blipFill>
-          <a:blip r:embed="rId2"/>
-          <a:stretch>
-            <a:fillRect/>
-          </a:stretch>
-        </p:blipFill>
-        <p:spPr bwMode="auto">
-          <a:xfrm>
-            <a:off x="4127500" y="1930400"/>
-            <a:ext cx="7010400" cy="3505200"/>
-          </a:xfrm>
-          <a:prstGeom prst="rect">
-            <a:avLst/>
-          </a:prstGeom>
-          <a:noFill/>
-          <a:ln w="9525">
-            <a:noFill/>
-            <a:headEnd/>
-            <a:tailEnd/>
-          </a:ln>
-        </p:spPr>
-      </p:pic>
+              <a:t>7. Main results - Health and Safety</a:t>
+            </a:r>
+          </a:p>
+        </p:txBody>
+      </p:sp>
     </p:spTree>
   </p:cSld>
 </p:sld>
@@ -6520,7 +6496,7 @@
             </a:pPr>
             <a:r>
               <a:rPr/>
-              <a:t>1.1 Headlines and Highlights (1)</a:t>
+              <a:t>1.1 (1)</a:t>
             </a:r>
           </a:p>
         </p:txBody>
@@ -6543,42 +6519,42 @@
             <a:pPr lvl="0"/>
             <a:r>
               <a:rPr/>
-              <a:t>The NHP program advocates for SBR design for new hospitals</a:t>
+              <a:t>The NHP program advocates for a majority single-bedded inpatient room (SBR) design for new hospitals.</a:t>
             </a:r>
           </a:p>
           <a:p>
             <a:pPr lvl="0"/>
             <a:r>
               <a:rPr/>
-              <a:t>Assumption that doing so will reduce inpatient length of stay (circa 12%)</a:t>
+              <a:t>There is a planning assumption that doing so will reduce average inpatient lengths of stay (circa 12%).</a:t>
             </a:r>
           </a:p>
           <a:p>
             <a:pPr lvl="0"/>
             <a:r>
               <a:rPr/>
-              <a:t>The challenge, therefore, is to quantify changes in LoS and a range of other potential impacts for 7 natural experiments between 2010 and 2022</a:t>
+              <a:t>Given the absence of strong and consistent evidence to support this, our challenge was to quantify changes in LoS and a range of other potential impacts for 7 natural experiments in SBR between 2010 and 2022.</a:t>
             </a:r>
           </a:p>
           <a:p>
             <a:pPr lvl="0"/>
             <a:r>
               <a:rPr/>
-              <a:t>Identified 12 impact measures</a:t>
+              <a:t>We have identified 12 impact measures from routinely collected or published data to assess for pre-post effects.</a:t>
             </a:r>
           </a:p>
           <a:p>
             <a:pPr lvl="0"/>
             <a:r>
               <a:rPr/>
-              <a:t>Used an approach called Causal Impact Analysis to detect pre-post changes in trend</a:t>
+              <a:t>We used an approach called Causal Impact Analysis (CIA) to detect and quantify those pre-post changes in trend.</a:t>
             </a:r>
           </a:p>
           <a:p>
             <a:pPr lvl="0"/>
             <a:r>
               <a:rPr/>
-              <a:t>Results (much like the published literature) are mixed…</a:t>
+              <a:t>The results of our analysis, much like the published literature, are mixed.</a:t>
             </a:r>
           </a:p>
         </p:txBody>
@@ -6630,7 +6606,7 @@
             </a:pPr>
             <a:r>
               <a:rPr/>
-              <a:t>7.2 In-hospital falls and injuries</a:t>
+              <a:t>7.1 In-hospital deaths</a:t>
             </a:r>
           </a:p>
         </p:txBody>
@@ -6686,14 +6662,14 @@
             </a:pPr>
             <a:r>
               <a:rPr/>
-              <a:t>The rate of in-hospital falls and injuries (% of spells) significantly decreased at 1/4 sites (Peterborough), and was unchanged at 3/4 sites (Royal Liverpool, Tunbridge Wells and Southmead).</a:t>
+              <a:t>The rate of in-hospital deaths (number per 1,000 discharges) significantly decreased at 1/5 sites (Peterborough), and was unchanged at 4/5 sites (Royal Liverpool, Tunbridge Wells, Clatterbridge and Southmead).</a:t>
             </a:r>
           </a:p>
         </p:txBody>
       </p:sp>
       <p:pic>
         <p:nvPicPr>
-          <p:cNvPr descr="NHP_SBR-impacts_2024_summaryfinal_files/figure-pptx/cia_falls-1.png" id="0" name="Picture 1"/>
+          <p:cNvPr descr="NHP_SBR-impacts_2024_summaryfinal_files/figure-pptx/cia_mort-1.png" id="0" name="Picture 1"/>
           <p:cNvPicPr>
             <a:picLocks noGrp="1" noChangeAspect="1"/>
           </p:cNvPicPr>
@@ -6768,7 +6744,7 @@
             </a:pPr>
             <a:r>
               <a:rPr/>
-              <a:t>7.3 Healthcare Acquired Infections (HCAI) - clostridium dificile</a:t>
+              <a:t>7.2 In-hospital falls and injuries</a:t>
             </a:r>
           </a:p>
         </p:txBody>
@@ -6811,11 +6787,11 @@
             </a:r>
             <a:r>
               <a:rPr b="1"/>
-              <a:t>provider level</a:t>
-            </a:r>
-            <a:r>
-              <a:rPr/>
-              <a:t> is taken from published UKHSA surveillance data (via UDAL).</a:t>
+              <a:t>site level</a:t>
+            </a:r>
+            <a:r>
+              <a:rPr/>
+              <a:t> is derived from SUS admitted patient care records.</a:t>
             </a:r>
           </a:p>
           <a:p>
@@ -6824,14 +6800,14 @@
             </a:pPr>
             <a:r>
               <a:rPr/>
-              <a:t>The rate of healthcare acquired C. difficile infections (cases per 10,000 bed days) decreased at 2/3 sites (Chase Farm and Southmead) but was unchanged at Royal Liverpool.</a:t>
+              <a:t>The rate of in-hospital falls and injuries (% of spells) significantly decreased at 1/4 sites (Peterborough), and was unchanged at 3/4 sites (Royal Liverpool, Tunbridge Wells and Southmead).</a:t>
             </a:r>
           </a:p>
         </p:txBody>
       </p:sp>
       <p:pic>
         <p:nvPicPr>
-          <p:cNvPr descr="NHP_SBR-impacts_2024_summaryfinal_files/figure-pptx/cia_hcai-1.png" id="0" name="Picture 1"/>
+          <p:cNvPr descr="NHP_SBR-impacts_2024_summaryfinal_files/figure-pptx/cia_falls-1.png" id="0" name="Picture 1"/>
           <p:cNvPicPr>
             <a:picLocks noGrp="1" noChangeAspect="1"/>
           </p:cNvPicPr>
@@ -6888,13 +6864,13 @@
             <a:spLocks noGrp="1"/>
           </p:cNvSpPr>
           <p:nvPr>
-            <p:ph hasCustomPrompt="1" type="ctrTitle"/>
+            <p:ph hasCustomPrompt="1" type="title"/>
           </p:nvPr>
         </p:nvSpPr>
         <p:spPr>
           <a:xfrm>
-            <a:off x="457199" y="4665306"/>
-            <a:ext cx="7772400" cy="1308413"/>
+            <a:off x="909829" y="438150"/>
+            <a:ext cx="8434196" cy="914400"/>
           </a:xfrm>
         </p:spPr>
         <p:txBody>
@@ -6906,11 +6882,97 @@
             </a:pPr>
             <a:r>
               <a:rPr/>
-              <a:t>8. Main results - Patient and Staff Experience</a:t>
-            </a:r>
-          </a:p>
-        </p:txBody>
-      </p:sp>
+              <a:t>7.3 Healthcare Acquired Infections (HCAI) - clostridium dificile</a:t>
+            </a:r>
+          </a:p>
+        </p:txBody>
+      </p:sp>
+      <p:sp>
+        <p:nvSpPr>
+          <p:cNvPr id="7" name="Text Placeholder 6">
+            <a:extLst>
+              <a:ext uri="{FF2B5EF4-FFF2-40B4-BE49-F238E27FC236}">
+                <a16:creationId xmlns:a16="http://schemas.microsoft.com/office/drawing/2014/main" id="{DE622849-4EA7-24AE-DD96-E693EAA81594}"/>
+              </a:ext>
+            </a:extLst>
+          </p:cNvPr>
+          <p:cNvSpPr>
+            <a:spLocks noGrp="1"/>
+          </p:cNvSpPr>
+          <p:nvPr>
+            <p:ph idx="13" sz="quarter" type="body"/>
+          </p:nvPr>
+        </p:nvSpPr>
+        <p:spPr/>
+        <p:txBody>
+          <a:bodyPr/>
+          <a:lstStyle/>
+          <a:p>
+            <a:pPr lvl="0" indent="0" marL="0">
+              <a:buNone/>
+            </a:pPr>
+            <a:r>
+              <a:rPr/>
+              <a:t>This </a:t>
+            </a:r>
+            <a:r>
+              <a:rPr b="1"/>
+              <a:t>monthly</a:t>
+            </a:r>
+            <a:r>
+              <a:rPr/>
+              <a:t> data at </a:t>
+            </a:r>
+            <a:r>
+              <a:rPr b="1"/>
+              <a:t>provider level</a:t>
+            </a:r>
+            <a:r>
+              <a:rPr/>
+              <a:t> is taken from published UKHSA surveillance data (via UDAL).</a:t>
+            </a:r>
+          </a:p>
+          <a:p>
+            <a:pPr lvl="0" indent="0" marL="0">
+              <a:buNone/>
+            </a:pPr>
+            <a:r>
+              <a:rPr/>
+              <a:t>The rate of healthcare acquired C. difficile infections (cases per 10,000 bed days) decreased at 2/3 sites (Chase Farm and Southmead) but was unchanged at Royal Liverpool.</a:t>
+            </a:r>
+          </a:p>
+        </p:txBody>
+      </p:sp>
+      <p:pic>
+        <p:nvPicPr>
+          <p:cNvPr descr="NHP_SBR-impacts_2024_summaryfinal_files/figure-pptx/cia_hcai-1.png" id="0" name="Picture 1"/>
+          <p:cNvPicPr>
+            <a:picLocks noGrp="1" noChangeAspect="1"/>
+          </p:cNvPicPr>
+          <p:nvPr/>
+        </p:nvPicPr>
+        <p:blipFill>
+          <a:blip r:embed="rId2"/>
+          <a:stretch>
+            <a:fillRect/>
+          </a:stretch>
+        </p:blipFill>
+        <p:spPr bwMode="auto">
+          <a:xfrm>
+            <a:off x="4127500" y="1930400"/>
+            <a:ext cx="7010400" cy="3505200"/>
+          </a:xfrm>
+          <a:prstGeom prst="rect">
+            <a:avLst/>
+          </a:prstGeom>
+          <a:noFill/>
+          <a:ln w="9525">
+            <a:noFill/>
+            <a:headEnd/>
+            <a:tailEnd/>
+          </a:ln>
+        </p:spPr>
+      </p:pic>
     </p:spTree>
   </p:cSld>
 </p:sld>
@@ -6940,13 +7002,13 @@
             <a:spLocks noGrp="1"/>
           </p:cNvSpPr>
           <p:nvPr>
-            <p:ph hasCustomPrompt="1" type="title"/>
+            <p:ph hasCustomPrompt="1" type="ctrTitle"/>
           </p:nvPr>
         </p:nvSpPr>
         <p:spPr>
           <a:xfrm>
-            <a:off x="909829" y="438150"/>
-            <a:ext cx="8434196" cy="914400"/>
+            <a:off x="457199" y="4665306"/>
+            <a:ext cx="7772400" cy="1308413"/>
           </a:xfrm>
         </p:spPr>
         <p:txBody>
@@ -6958,97 +7020,11 @@
             </a:pPr>
             <a:r>
               <a:rPr/>
-              <a:t>8.1 Family and Friends test</a:t>
-            </a:r>
-          </a:p>
-        </p:txBody>
-      </p:sp>
-      <p:sp>
-        <p:nvSpPr>
-          <p:cNvPr id="7" name="Text Placeholder 6">
-            <a:extLst>
-              <a:ext uri="{FF2B5EF4-FFF2-40B4-BE49-F238E27FC236}">
-                <a16:creationId xmlns:a16="http://schemas.microsoft.com/office/drawing/2014/main" id="{DE622849-4EA7-24AE-DD96-E693EAA81594}"/>
-              </a:ext>
-            </a:extLst>
-          </p:cNvPr>
-          <p:cNvSpPr>
-            <a:spLocks noGrp="1"/>
-          </p:cNvSpPr>
-          <p:nvPr>
-            <p:ph idx="13" sz="quarter" type="body"/>
-          </p:nvPr>
-        </p:nvSpPr>
-        <p:spPr/>
-        <p:txBody>
-          <a:bodyPr/>
-          <a:lstStyle/>
-          <a:p>
-            <a:pPr lvl="0" indent="0" marL="0">
-              <a:buNone/>
-            </a:pPr>
-            <a:r>
-              <a:rPr/>
-              <a:t>This </a:t>
-            </a:r>
-            <a:r>
-              <a:rPr b="1"/>
-              <a:t>monthly</a:t>
-            </a:r>
-            <a:r>
-              <a:rPr/>
-              <a:t> data at </a:t>
-            </a:r>
-            <a:r>
-              <a:rPr b="1"/>
-              <a:t>site level</a:t>
-            </a:r>
-            <a:r>
-              <a:rPr/>
-              <a:t> is taken from published NHS England data (via UDAL).</a:t>
-            </a:r>
-          </a:p>
-          <a:p>
-            <a:pPr lvl="0" indent="0" marL="0">
-              <a:buNone/>
-            </a:pPr>
-            <a:r>
-              <a:rPr/>
-              <a:t>The percentage of positive responses significantly decreased at 1/5 sites (Clatterbridge), increased at 1/5 sites (Papworth) and was unchanged at the other 3/5 sites (Royal Liverpool, Southmead and Chase Farm).</a:t>
-            </a:r>
-          </a:p>
-        </p:txBody>
-      </p:sp>
-      <p:pic>
-        <p:nvPicPr>
-          <p:cNvPr descr="NHP_SBR-impacts_2024_summaryfinal_files/figure-pptx/cia_famfriend-1.png" id="0" name="Picture 1"/>
-          <p:cNvPicPr>
-            <a:picLocks noGrp="1" noChangeAspect="1"/>
-          </p:cNvPicPr>
-          <p:nvPr/>
-        </p:nvPicPr>
-        <p:blipFill>
-          <a:blip r:embed="rId2"/>
-          <a:stretch>
-            <a:fillRect/>
-          </a:stretch>
-        </p:blipFill>
-        <p:spPr bwMode="auto">
-          <a:xfrm>
-            <a:off x="4127500" y="1930400"/>
-            <a:ext cx="7010400" cy="3505200"/>
-          </a:xfrm>
-          <a:prstGeom prst="rect">
-            <a:avLst/>
-          </a:prstGeom>
-          <a:noFill/>
-          <a:ln w="9525">
-            <a:noFill/>
-            <a:headEnd/>
-            <a:tailEnd/>
-          </a:ln>
-        </p:spPr>
-      </p:pic>
+              <a:t>8. Main results - Patient and Staff Experience</a:t>
+            </a:r>
+          </a:p>
+        </p:txBody>
+      </p:sp>
     </p:spTree>
   </p:cSld>
 </p:sld>
@@ -7096,7 +7072,7 @@
             </a:pPr>
             <a:r>
               <a:rPr/>
-              <a:t>8.2 Staff sickness absence</a:t>
+              <a:t>8.1 Family and Friends test</a:t>
             </a:r>
           </a:p>
         </p:txBody>
@@ -7139,7 +7115,7 @@
             </a:r>
             <a:r>
               <a:rPr b="1"/>
-              <a:t>provider level</a:t>
+              <a:t>site level</a:t>
             </a:r>
             <a:r>
               <a:rPr/>
@@ -7152,14 +7128,14 @@
             </a:pPr>
             <a:r>
               <a:rPr/>
-              <a:t>The percentage of available days taken off sick by staff significantly increased at 2/7 sites (Southmead and Tunbridge Wells) and was unchanged at the remaining 5 sites.</a:t>
+              <a:t>The percentage of positive responses significantly decreased at 1/5 sites (Clatterbridge), increased at 1/5 sites (Papworth) and was unchanged at the other 3/5 sites (Royal Liverpool, Southmead and Chase Farm).</a:t>
             </a:r>
           </a:p>
         </p:txBody>
       </p:sp>
       <p:pic>
         <p:nvPicPr>
-          <p:cNvPr descr="NHP_SBR-impacts_2024_summaryfinal_files/figure-pptx/cia_sick-1.png" id="0" name="Picture 1"/>
+          <p:cNvPr descr="NHP_SBR-impacts_2024_summaryfinal_files/figure-pptx/cia_famfriend-1.png" id="0" name="Picture 1"/>
           <p:cNvPicPr>
             <a:picLocks noGrp="1" noChangeAspect="1"/>
           </p:cNvPicPr>
@@ -7234,7 +7210,7 @@
             </a:pPr>
             <a:r>
               <a:rPr/>
-              <a:t>8.3 Staff turnover</a:t>
+              <a:t>8.2 Staff sickness absence</a:t>
             </a:r>
           </a:p>
         </p:txBody>
@@ -7290,14 +7266,14 @@
             </a:pPr>
             <a:r>
               <a:rPr/>
-              <a:t>Staff turnover measured as percentage of staff leaving was not significantly changed at any of the 3 sites where data was available.</a:t>
+              <a:t>The percentage of available days taken off sick by staff significantly increased at 2/7 sites (Southmead and Tunbridge Wells) and was unchanged at the remaining 5 sites.</a:t>
             </a:r>
           </a:p>
         </p:txBody>
       </p:sp>
       <p:pic>
         <p:nvPicPr>
-          <p:cNvPr descr="NHP_SBR-impacts_2024_summaryfinal_files/figure-pptx/cia_turnover-1.png" id="0" name="Picture 1"/>
+          <p:cNvPr descr="NHP_SBR-impacts_2024_summaryfinal_files/figure-pptx/cia_sick-1.png" id="0" name="Picture 1"/>
           <p:cNvPicPr>
             <a:picLocks noGrp="1" noChangeAspect="1"/>
           </p:cNvPicPr>
@@ -7372,7 +7348,7 @@
             </a:pPr>
             <a:r>
               <a:rPr/>
-              <a:t>8.4 Staff survey - recommending place to work</a:t>
+              <a:t>8.3 Staff turnover</a:t>
             </a:r>
           </a:p>
         </p:txBody>
@@ -7428,14 +7404,14 @@
             </a:pPr>
             <a:r>
               <a:rPr/>
-              <a:t>The percentage of staff that would recommend their trust as a place to work significantly increased at 1/6 sites (Papworth), and was unchanged at 3/6 (Chase Farm, Royal Liverpool and Tunbridge Wells). At 2/6 sites (Southmead and Clatterbridge) there was a significant decrease in the percentage that would recommend their trust as a place to work.</a:t>
+              <a:t>Staff turnover measured as percentage of staff leaving was not significantly changed at any of the 3 sites where data was available.</a:t>
             </a:r>
           </a:p>
         </p:txBody>
       </p:sp>
       <p:pic>
         <p:nvPicPr>
-          <p:cNvPr descr="NHP_SBR-impacts_2024_summaryfinal_files/figure-pptx/cia_survey-1.png" id="0" name="Picture 1"/>
+          <p:cNvPr descr="NHP_SBR-impacts_2024_summaryfinal_files/figure-pptx/cia_turnover-1.png" id="0" name="Picture 1"/>
           <p:cNvPicPr>
             <a:picLocks noGrp="1" noChangeAspect="1"/>
           </p:cNvPicPr>
@@ -7492,13 +7468,13 @@
             <a:spLocks noGrp="1"/>
           </p:cNvSpPr>
           <p:nvPr>
-            <p:ph hasCustomPrompt="1" type="ctrTitle"/>
+            <p:ph hasCustomPrompt="1" type="title"/>
           </p:nvPr>
         </p:nvSpPr>
         <p:spPr>
           <a:xfrm>
-            <a:off x="457199" y="4665306"/>
-            <a:ext cx="7772400" cy="1308413"/>
+            <a:off x="909829" y="438150"/>
+            <a:ext cx="8434196" cy="914400"/>
           </a:xfrm>
         </p:spPr>
         <p:txBody>
@@ -7510,11 +7486,97 @@
             </a:pPr>
             <a:r>
               <a:rPr/>
-              <a:t>9. Next steps and actions</a:t>
-            </a:r>
-          </a:p>
-        </p:txBody>
-      </p:sp>
+              <a:t>8.4 Staff survey - recommending place to work</a:t>
+            </a:r>
+          </a:p>
+        </p:txBody>
+      </p:sp>
+      <p:sp>
+        <p:nvSpPr>
+          <p:cNvPr id="7" name="Text Placeholder 6">
+            <a:extLst>
+              <a:ext uri="{FF2B5EF4-FFF2-40B4-BE49-F238E27FC236}">
+                <a16:creationId xmlns:a16="http://schemas.microsoft.com/office/drawing/2014/main" id="{DE622849-4EA7-24AE-DD96-E693EAA81594}"/>
+              </a:ext>
+            </a:extLst>
+          </p:cNvPr>
+          <p:cNvSpPr>
+            <a:spLocks noGrp="1"/>
+          </p:cNvSpPr>
+          <p:nvPr>
+            <p:ph idx="13" sz="quarter" type="body"/>
+          </p:nvPr>
+        </p:nvSpPr>
+        <p:spPr/>
+        <p:txBody>
+          <a:bodyPr/>
+          <a:lstStyle/>
+          <a:p>
+            <a:pPr lvl="0" indent="0" marL="0">
+              <a:buNone/>
+            </a:pPr>
+            <a:r>
+              <a:rPr/>
+              <a:t>This </a:t>
+            </a:r>
+            <a:r>
+              <a:rPr b="1"/>
+              <a:t>monthly</a:t>
+            </a:r>
+            <a:r>
+              <a:rPr/>
+              <a:t> data at </a:t>
+            </a:r>
+            <a:r>
+              <a:rPr b="1"/>
+              <a:t>provider level</a:t>
+            </a:r>
+            <a:r>
+              <a:rPr/>
+              <a:t> is taken from published NHS England data (via UDAL).</a:t>
+            </a:r>
+          </a:p>
+          <a:p>
+            <a:pPr lvl="0" indent="0" marL="0">
+              <a:buNone/>
+            </a:pPr>
+            <a:r>
+              <a:rPr/>
+              <a:t>The percentage of staff that would recommend their trust as a place to work significantly increased at 1/6 sites (Papworth), and was unchanged at 3/6 (Chase Farm, Royal Liverpool and Tunbridge Wells). At 2/6 sites (Southmead and Clatterbridge) there was a significant decrease in the percentage that would recommend their trust as a place to work.</a:t>
+            </a:r>
+          </a:p>
+        </p:txBody>
+      </p:sp>
+      <p:pic>
+        <p:nvPicPr>
+          <p:cNvPr descr="NHP_SBR-impacts_2024_summaryfinal_files/figure-pptx/cia_survey-1.png" id="0" name="Picture 1"/>
+          <p:cNvPicPr>
+            <a:picLocks noGrp="1" noChangeAspect="1"/>
+          </p:cNvPicPr>
+          <p:nvPr/>
+        </p:nvPicPr>
+        <p:blipFill>
+          <a:blip r:embed="rId2"/>
+          <a:stretch>
+            <a:fillRect/>
+          </a:stretch>
+        </p:blipFill>
+        <p:spPr bwMode="auto">
+          <a:xfrm>
+            <a:off x="4127500" y="1930400"/>
+            <a:ext cx="7010400" cy="3505200"/>
+          </a:xfrm>
+          <a:prstGeom prst="rect">
+            <a:avLst/>
+          </a:prstGeom>
+          <a:noFill/>
+          <a:ln w="9525">
+            <a:noFill/>
+            <a:headEnd/>
+            <a:tailEnd/>
+          </a:ln>
+        </p:spPr>
+      </p:pic>
     </p:spTree>
   </p:cSld>
 </p:sld>
@@ -7544,13 +7606,13 @@
             <a:spLocks noGrp="1"/>
           </p:cNvSpPr>
           <p:nvPr>
-            <p:ph hasCustomPrompt="1" type="title"/>
+            <p:ph hasCustomPrompt="1" type="ctrTitle"/>
           </p:nvPr>
         </p:nvSpPr>
         <p:spPr>
           <a:xfrm>
-            <a:off x="909829" y="403765"/>
-            <a:ext cx="8434196" cy="976056"/>
+            <a:off x="457199" y="4665306"/>
+            <a:ext cx="7772400" cy="1308413"/>
           </a:xfrm>
         </p:spPr>
         <p:txBody>
@@ -7562,51 +7624,7 @@
             </a:pPr>
             <a:r>
               <a:rPr/>
-              <a:t>9.1 Still on the to-do list…</a:t>
-            </a:r>
-          </a:p>
-        </p:txBody>
-      </p:sp>
-      <p:sp>
-        <p:nvSpPr>
-          <p:cNvPr id="3" name="Content Placeholder 2"/>
-          <p:cNvSpPr>
-            <a:spLocks noGrp="1"/>
-          </p:cNvSpPr>
-          <p:nvPr>
-            <p:ph idx="1"/>
-          </p:nvPr>
-        </p:nvSpPr>
-        <p:spPr/>
-        <p:txBody>
-          <a:bodyPr/>
-          <a:lstStyle/>
-          <a:p>
-            <a:pPr lvl="0"/>
-            <a:r>
-              <a:rPr/>
-              <a:t>NHP planning and modelling teams consider for inclusion in assumptions</a:t>
-            </a:r>
-          </a:p>
-          <a:p>
-            <a:pPr lvl="0"/>
-            <a:r>
-              <a:rPr/>
-              <a:t>Supporting development of monitoring and evaluation framework for NHP/SBR</a:t>
-            </a:r>
-          </a:p>
-          <a:p>
-            <a:pPr lvl="0"/>
-            <a:r>
-              <a:rPr/>
-              <a:t>Engage with the 7 providers in the study (booked Dec ’24) in terms of sharing of the findings in public domain</a:t>
-            </a:r>
-          </a:p>
-          <a:p>
-            <a:pPr lvl="0"/>
-            <a:r>
-              <a:rPr/>
-              <a:t>Pursue peer-reviewed journal publication (BMJ open)</a:t>
+              <a:t>9. Next steps and actions</a:t>
             </a:r>
           </a:p>
         </p:txBody>
@@ -7640,13 +7658,13 @@
             <a:spLocks noGrp="1"/>
           </p:cNvSpPr>
           <p:nvPr>
-            <p:ph hasCustomPrompt="1" type="ctrTitle"/>
+            <p:ph hasCustomPrompt="1" type="title"/>
           </p:nvPr>
         </p:nvSpPr>
         <p:spPr>
           <a:xfrm>
-            <a:off x="457199" y="4665306"/>
-            <a:ext cx="7772400" cy="1308413"/>
+            <a:off x="909829" y="403765"/>
+            <a:ext cx="8434196" cy="976056"/>
           </a:xfrm>
         </p:spPr>
         <p:txBody>
@@ -7658,7 +7676,51 @@
             </a:pPr>
             <a:r>
               <a:rPr/>
-              <a:t>10. Acknowledgements</a:t>
+              <a:t>9.1 Ongoing and related activities</a:t>
+            </a:r>
+          </a:p>
+        </p:txBody>
+      </p:sp>
+      <p:sp>
+        <p:nvSpPr>
+          <p:cNvPr id="3" name="Content Placeholder 2"/>
+          <p:cNvSpPr>
+            <a:spLocks noGrp="1"/>
+          </p:cNvSpPr>
+          <p:nvPr>
+            <p:ph idx="1"/>
+          </p:nvPr>
+        </p:nvSpPr>
+        <p:spPr/>
+        <p:txBody>
+          <a:bodyPr/>
+          <a:lstStyle/>
+          <a:p>
+            <a:pPr lvl="0"/>
+            <a:r>
+              <a:rPr/>
+              <a:t>Discussing the NHP response to these findings (today’s session)</a:t>
+            </a:r>
+          </a:p>
+          <a:p>
+            <a:pPr lvl="0"/>
+            <a:r>
+              <a:rPr/>
+              <a:t>NHP planning and modelling teams consider findings for inclusion in assumptions and demand &amp; capacity inflation and mitigation.</a:t>
+            </a:r>
+          </a:p>
+          <a:p>
+            <a:pPr lvl="0"/>
+            <a:r>
+              <a:rPr/>
+              <a:t>Supporting development of monitoring and evaluation framework for NHP/SBR.</a:t>
+            </a:r>
+          </a:p>
+          <a:p>
+            <a:pPr lvl="0"/>
+            <a:r>
+              <a:rPr/>
+              <a:t>Engage with the 7 providers in the study in terms of sharing of these findings in the public domain?</a:t>
             </a:r>
           </a:p>
         </p:txBody>
@@ -7710,7 +7772,7 @@
             </a:pPr>
             <a:r>
               <a:rPr/>
-              <a:t>1.2 Headlines and Highlights (2)</a:t>
+              <a:t>1.2 (2)</a:t>
             </a:r>
           </a:p>
         </p:txBody>
@@ -7735,7 +7797,7 @@
             </a:pPr>
             <a:r>
               <a:rPr/>
-              <a:t>There were no overall significant findings in relation to impacts of changes to SBR provision, although there were instances of significant effects at individual sites. There are contextual factors not measured within our analysis which will likely have exacerbated or mitigated the effects.</a:t>
+              <a:t>There were no overall significant findings in relation to impacts of changes to SBR provision, although there were instances of significant impact on some measures at individual sites. There are contextual factors not accounted for within our analysis which will likely have exacerbated or mitigated the effects.</a:t>
             </a:r>
           </a:p>
           <a:p>
@@ -7744,52 +7806,16 @@
             </a:pPr>
             <a:r>
               <a:rPr/>
-              <a:t>In general terms however:</a:t>
-            </a:r>
-          </a:p>
-          <a:p>
-            <a:pPr lvl="0"/>
-            <a:r>
-              <a:rPr/>
-              <a:t>For </a:t>
-            </a:r>
-            <a:r>
-              <a:rPr b="1"/>
-              <a:t>productivity and Efficiency</a:t>
-            </a:r>
-            <a:r>
-              <a:rPr/>
-              <a:t> measures, length of stay improved (4/6), waiting times reduced (3/5), Bed Occupancy increased (3/4), Emergency re-admissions fell (4/7), cleaning costs reduced (2/3)</a:t>
-            </a:r>
-          </a:p>
-          <a:p>
-            <a:pPr lvl="0"/>
-            <a:r>
-              <a:rPr/>
-              <a:t>For </a:t>
-            </a:r>
-            <a:r>
-              <a:rPr b="1"/>
-              <a:t>health and safety</a:t>
-            </a:r>
-            <a:r>
-              <a:rPr/>
-              <a:t> measures, in-hospital deaths fell (3/5), falls and injuries increased (3/4), HCAI reduced (3/3)</a:t>
-            </a:r>
-          </a:p>
-          <a:p>
-            <a:pPr lvl="0"/>
-            <a:r>
-              <a:rPr/>
-              <a:t>For </a:t>
-            </a:r>
-            <a:r>
-              <a:rPr b="1"/>
-              <a:t>patient &amp; staff experiences</a:t>
-            </a:r>
-            <a:r>
-              <a:rPr/>
-              <a:t>, friends and family scores increased (3/5), staff sickness increased (4/7), staff turnover fell (3/3), staff satisfaction reduced (4/6).</a:t>
+              <a:t>For bed occupancy, emergency readmissions, cleaning costs and all health and safety measures there were either positive effects or no significant change. However, positive, negative and no effects were seen for length of stay, waiting time, patient experience, and staff experience measures. Where there were immediate positive or negative impacts on a metric, these often regressed back towards prior levels over the longer-term (2 years).</a:t>
+            </a:r>
+          </a:p>
+          <a:p>
+            <a:pPr lvl="0" indent="0" marL="0">
+              <a:buNone/>
+            </a:pPr>
+            <a:r>
+              <a:rPr/>
+              <a:t>Reduced length of stay could potentially help offset additional costs associated with single room hospitals, however, at general acute hospitals there was no significant change in length of stay (7% reduction (-17% to 2% 95% CI)). At general acute hospitals the proportion of staff recommending their trust as a place to work significantly decreased by 15% (-23% to -6% 95% CI) and staff sickness absences increased by 6% (1% to 12% 95% CI).</a:t>
             </a:r>
           </a:p>
         </p:txBody>
@@ -7823,6 +7849,58 @@
             <a:spLocks noGrp="1"/>
           </p:cNvSpPr>
           <p:nvPr>
+            <p:ph hasCustomPrompt="1" type="ctrTitle"/>
+          </p:nvPr>
+        </p:nvSpPr>
+        <p:spPr>
+          <a:xfrm>
+            <a:off x="457199" y="4665306"/>
+            <a:ext cx="7772400" cy="1308413"/>
+          </a:xfrm>
+        </p:spPr>
+        <p:txBody>
+          <a:bodyPr/>
+          <a:lstStyle/>
+          <a:p>
+            <a:pPr lvl="0" indent="0" marL="0">
+              <a:buNone/>
+            </a:pPr>
+            <a:r>
+              <a:rPr/>
+              <a:t>10. Acknowledgements</a:t>
+            </a:r>
+          </a:p>
+        </p:txBody>
+      </p:sp>
+    </p:spTree>
+  </p:cSld>
+</p:sld>
+</file>
+
+<file path=ppt/slides/slide41.xml><?xml version="1.0" encoding="utf-8"?>
+<p:sld xmlns:a="http://schemas.openxmlformats.org/drawingml/2006/main" xmlns:r="http://schemas.openxmlformats.org/officeDocument/2006/relationships" xmlns:p="http://schemas.openxmlformats.org/presentationml/2006/main">
+  <p:cSld>
+    <p:spTree>
+      <p:nvGrpSpPr>
+        <p:cNvPr id="1" name=""/>
+        <p:cNvGrpSpPr/>
+        <p:nvPr/>
+      </p:nvGrpSpPr>
+      <p:grpSpPr>
+        <a:xfrm>
+          <a:off x="0" y="0"/>
+          <a:ext cx="0" cy="0"/>
+          <a:chOff x="0" y="0"/>
+          <a:chExt cx="0" cy="0"/>
+        </a:xfrm>
+      </p:grpSpPr>
+      <p:sp>
+        <p:nvSpPr>
+          <p:cNvPr id="2" name="Title 1"/>
+          <p:cNvSpPr>
+            <a:spLocks noGrp="1"/>
+          </p:cNvSpPr>
+          <p:nvPr>
             <p:ph hasCustomPrompt="1" type="title"/>
           </p:nvPr>
         </p:nvSpPr>
@@ -7930,13 +8008,13 @@
             <a:spLocks noGrp="1"/>
           </p:cNvSpPr>
           <p:nvPr>
-            <p:ph hasCustomPrompt="1" type="ctrTitle"/>
+            <p:ph hasCustomPrompt="1" type="title"/>
           </p:nvPr>
         </p:nvSpPr>
         <p:spPr>
           <a:xfrm>
-            <a:off x="457199" y="4665306"/>
-            <a:ext cx="7772400" cy="1308413"/>
+            <a:off x="909829" y="403765"/>
+            <a:ext cx="8434196" cy="976056"/>
           </a:xfrm>
         </p:spPr>
         <p:txBody>
@@ -7948,7 +8026,41 @@
             </a:pPr>
             <a:r>
               <a:rPr/>
-              <a:t>2. Introduction, approach, summary and recommendations</a:t>
+              <a:t>1.3 (3)</a:t>
+            </a:r>
+          </a:p>
+        </p:txBody>
+      </p:sp>
+      <p:sp>
+        <p:nvSpPr>
+          <p:cNvPr id="3" name="Content Placeholder 2"/>
+          <p:cNvSpPr>
+            <a:spLocks noGrp="1"/>
+          </p:cNvSpPr>
+          <p:nvPr>
+            <p:ph idx="1"/>
+          </p:nvPr>
+        </p:nvSpPr>
+        <p:spPr/>
+        <p:txBody>
+          <a:bodyPr/>
+          <a:lstStyle/>
+          <a:p>
+            <a:pPr lvl="0" indent="0" marL="0">
+              <a:buNone/>
+            </a:pPr>
+            <a:r>
+              <a:rPr/>
+              <a:t>For planning purposes, the NHP may want to take a more conservative approach to modelling the impact on LoS of SBR but also consider other potential efficiency gains i.e. reduced waiting times, reduction in falls/injuries and infections. Additionally, acknowledging the potential adverse impacts on staff experiences, qualitative monitoring of impacts would aid in implementation and mitigation strategies.</a:t>
+            </a:r>
+          </a:p>
+          <a:p>
+            <a:pPr lvl="0" indent="0" marL="0">
+              <a:buNone/>
+            </a:pPr>
+            <a:r>
+              <a:rPr/>
+              <a:t>For both SBR impacts and broader programme evaluation, a prospective monitoring framework of these indicators and more would support and develop the evidence-base for hospital design and builds in the future.</a:t>
             </a:r>
           </a:p>
         </p:txBody>
@@ -7982,13 +8094,13 @@
             <a:spLocks noGrp="1"/>
           </p:cNvSpPr>
           <p:nvPr>
-            <p:ph type="title"/>
+            <p:ph hasCustomPrompt="1" type="ctrTitle"/>
           </p:nvPr>
         </p:nvSpPr>
         <p:spPr>
           <a:xfrm>
-            <a:off x="919352" y="419100"/>
-            <a:ext cx="9720072" cy="933450"/>
+            <a:off x="457199" y="4665306"/>
+            <a:ext cx="7772400" cy="1308413"/>
           </a:xfrm>
         </p:spPr>
         <p:txBody>
@@ -8000,78 +8112,7 @@
             </a:pPr>
             <a:r>
               <a:rPr/>
-              <a:t>2.1 Introduction</a:t>
-            </a:r>
-          </a:p>
-        </p:txBody>
-      </p:sp>
-      <p:sp>
-        <p:nvSpPr>
-          <p:cNvPr id="3" name="Content Placeholder 2">
-            <a:extLst>
-              <a:ext uri="{FF2B5EF4-FFF2-40B4-BE49-F238E27FC236}">
-                <a16:creationId xmlns:a16="http://schemas.microsoft.com/office/drawing/2014/main" id="{D2592819-5C80-B996-F823-F8B9F9EAD6C9}"/>
-              </a:ext>
-            </a:extLst>
-          </p:cNvPr>
-          <p:cNvSpPr>
-            <a:spLocks noGrp="1"/>
-          </p:cNvSpPr>
-          <p:nvPr>
-            <p:ph idx="10"/>
-          </p:nvPr>
-        </p:nvSpPr>
-        <p:spPr/>
-        <p:txBody>
-          <a:bodyPr/>
-          <a:lstStyle/>
-          <a:p>
-            <a:pPr lvl="0" indent="0" marL="0">
-              <a:buNone/>
-            </a:pPr>
-            <a:r>
-              <a:rPr/>
-              <a:t>Since it’s inception, the New Hospital Programme (NHP) has advocated for single bed rooms (SBR). The grounds for this are based on a range of guidance, evidence and previous policy statements of intent. Whilst that position is unequivocal, there is uncertainty around the quantification of impacts of such a change and thus the assumptions that feed into demand and capacity models and economic business cases for current and future new hospital developments.</a:t>
-            </a:r>
-          </a:p>
-        </p:txBody>
-      </p:sp>
-      <p:sp>
-        <p:nvSpPr>
-          <p:cNvPr id="4" name="Content Placeholder 2">
-            <a:extLst>
-              <a:ext uri="{FF2B5EF4-FFF2-40B4-BE49-F238E27FC236}">
-                <a16:creationId xmlns:a16="http://schemas.microsoft.com/office/drawing/2014/main" id="{D1BAB7DA-EC53-0103-E362-83F86BDB6BC4}"/>
-              </a:ext>
-            </a:extLst>
-          </p:cNvPr>
-          <p:cNvSpPr>
-            <a:spLocks noGrp="1"/>
-          </p:cNvSpPr>
-          <p:nvPr>
-            <p:ph idx="11"/>
-          </p:nvPr>
-        </p:nvSpPr>
-        <p:spPr/>
-        <p:txBody>
-          <a:bodyPr/>
-          <a:lstStyle/>
-          <a:p>
-            <a:pPr lvl="0" indent="0" marL="0">
-              <a:buNone/>
-            </a:pPr>
-            <a:r>
-              <a:rPr/>
-              <a:t>Specifically, a starting assumption was that a length of stay reduction of 12% was likely for all new SBR facilities compared to prior trends. This assumption was criticised by the national audit office (NAO) (Office 2023) in the face of a mixed evidence base.</a:t>
-            </a:r>
-          </a:p>
-          <a:p>
-            <a:pPr lvl="0" indent="0" marL="0">
-              <a:buNone/>
-            </a:pPr>
-            <a:r>
-              <a:rPr/>
-              <a:t>It is the express aim of this analysis therefore to quantify the range of likely impacts for length of stay and a basket of other measures across patient &amp; staff experience, productivity and health &amp; safety.</a:t>
+              <a:t>2. Introduction, approach, summary and recommendations</a:t>
             </a:r>
           </a:p>
         </p:txBody>
@@ -8123,7 +8164,7 @@
             </a:pPr>
             <a:r>
               <a:rPr/>
-              <a:t>2.2 Approach</a:t>
+              <a:t>2.1 Introduction</a:t>
             </a:r>
           </a:p>
         </p:txBody>
@@ -8149,31 +8190,12 @@
           <a:bodyPr/>
           <a:lstStyle/>
           <a:p>
-            <a:pPr lvl="0"/>
-            <a:r>
-              <a:rPr/>
-              <a:t>Previous literature reviews and general searches were undertaken to identify potential impact factors.</a:t>
-            </a:r>
-          </a:p>
-          <a:p>
-            <a:pPr lvl="0"/>
-            <a:r>
-              <a:rPr/>
-              <a:t>Identified relevant measures or proxy measures from publicly available data and routine data sources.</a:t>
-            </a:r>
-          </a:p>
-          <a:p>
-            <a:pPr lvl="0"/>
-            <a:r>
-              <a:rPr/>
-              <a:t>Included only those with sufficient time series and of acceptable data quality into final impact framework.</a:t>
-            </a:r>
-          </a:p>
-          <a:p>
-            <a:pPr lvl="0"/>
-            <a:r>
-              <a:rPr/>
-              <a:t>Cleansed and compiled all the data into time series format.</a:t>
+            <a:pPr lvl="0" indent="0" marL="0">
+              <a:buNone/>
+            </a:pPr>
+            <a:r>
+              <a:rPr/>
+              <a:t>Since it’s inception, the New Hospital Programme (NHP) has advocated for single bedded inpatient rooms (SBR). The grounds for this are based on a range of guidance, evidence and previous policy statements of intent. Whilst that position is unequivocal, there is uncertainty around the quantification of impacts of such a change and thus the assumptions that feed into demand and capacity models and economic business cases for current and future new hospital developments.</a:t>
             </a:r>
           </a:p>
         </p:txBody>
@@ -8199,31 +8221,21 @@
           <a:bodyPr/>
           <a:lstStyle/>
           <a:p>
-            <a:pPr lvl="0"/>
-            <a:r>
-              <a:rPr/>
-              <a:t>Identified ‘control’ sites and providers to compare to our natural experiment sites.</a:t>
-            </a:r>
-          </a:p>
-          <a:p>
-            <a:pPr lvl="0"/>
-            <a:r>
-              <a:rPr/>
-              <a:t>Several stages of this matching according to hospital function, size, case-mix and admission ratio’s.</a:t>
-            </a:r>
-          </a:p>
-          <a:p>
-            <a:pPr lvl="0"/>
-            <a:r>
-              <a:rPr/>
-              <a:t>Performed causal impact analysis on the pre and post intervention periods to detect the nature and scale of impacts for each natural experiment.</a:t>
-            </a:r>
-          </a:p>
-          <a:p>
-            <a:pPr lvl="0"/>
-            <a:r>
-              <a:rPr/>
-              <a:t>Aggregated findings for the non-specialist hospitals.</a:t>
+            <a:pPr lvl="0" indent="0" marL="0">
+              <a:buNone/>
+            </a:pPr>
+            <a:r>
+              <a:rPr/>
+              <a:t>Specifically, a starting assumption was that a length of stay reduction of 12% was likely for all new SBR facilities compared to prior trends. This assumption was criticised by the national audit office (NAO) (Office 2023) in the face of a mixed evidence base.</a:t>
+            </a:r>
+          </a:p>
+          <a:p>
+            <a:pPr lvl="0" indent="0" marL="0">
+              <a:buNone/>
+            </a:pPr>
+            <a:r>
+              <a:rPr/>
+              <a:t>It is the express aim of this analysis therefore to quantify the range of likely impacts for length of stay and a basket of other measures across patient &amp; staff experience, productivity and health &amp; safety.</a:t>
             </a:r>
           </a:p>
         </p:txBody>
@@ -8257,13 +8269,13 @@
             <a:spLocks noGrp="1"/>
           </p:cNvSpPr>
           <p:nvPr>
-            <p:ph hasCustomPrompt="1" type="title"/>
+            <p:ph type="title"/>
           </p:nvPr>
         </p:nvSpPr>
         <p:spPr>
           <a:xfrm>
-            <a:off x="909829" y="403765"/>
-            <a:ext cx="8434196" cy="976056"/>
+            <a:off x="919352" y="419100"/>
+            <a:ext cx="9720072" cy="933450"/>
           </a:xfrm>
         </p:spPr>
         <p:txBody>
@@ -8275,19 +8287,25 @@
             </a:pPr>
             <a:r>
               <a:rPr/>
-              <a:t>2.3 Summary of key findings (1)</a:t>
-            </a:r>
-          </a:p>
-        </p:txBody>
-      </p:sp>
-      <p:sp>
-        <p:nvSpPr>
-          <p:cNvPr id="3" name="Content Placeholder 2"/>
-          <p:cNvSpPr>
-            <a:spLocks noGrp="1"/>
-          </p:cNvSpPr>
-          <p:nvPr>
-            <p:ph idx="1"/>
+              <a:t>2.2 Approach</a:t>
+            </a:r>
+          </a:p>
+        </p:txBody>
+      </p:sp>
+      <p:sp>
+        <p:nvSpPr>
+          <p:cNvPr id="3" name="Content Placeholder 2">
+            <a:extLst>
+              <a:ext uri="{FF2B5EF4-FFF2-40B4-BE49-F238E27FC236}">
+                <a16:creationId xmlns:a16="http://schemas.microsoft.com/office/drawing/2014/main" id="{D2592819-5C80-B996-F823-F8B9F9EAD6C9}"/>
+              </a:ext>
+            </a:extLst>
+          </p:cNvPr>
+          <p:cNvSpPr>
+            <a:spLocks noGrp="1"/>
+          </p:cNvSpPr>
+          <p:nvPr>
+            <p:ph idx="10"/>
           </p:nvPr>
         </p:nvSpPr>
         <p:spPr/>
@@ -8295,70 +8313,74 @@
           <a:bodyPr/>
           <a:lstStyle/>
           <a:p>
-            <a:pPr lvl="0" indent="0" marL="0">
-              <a:buNone/>
-            </a:pPr>
-            <a:r>
-              <a:rPr/>
-              <a:t>Our results are generally not consistent within indicators and across hospital sites. This inconsistency is reflective of the findings from published literature. Only two impact measures moved in the same direction across all (eligible) sites - </a:t>
-            </a:r>
-            <a:r>
-              <a:rPr b="1"/>
-              <a:t>C-diff decreasing</a:t>
-            </a:r>
-            <a:r>
-              <a:rPr/>
-              <a:t> and </a:t>
-            </a:r>
-            <a:r>
-              <a:rPr b="1"/>
-              <a:t>staff turnover decreasing</a:t>
-            </a:r>
-            <a:r>
-              <a:rPr/>
-              <a:t> and two measures were significant at the pooled general-acute level - </a:t>
-            </a:r>
-            <a:r>
-              <a:rPr b="1"/>
-              <a:t>staff sickness increasing</a:t>
-            </a:r>
-            <a:r>
-              <a:rPr/>
-              <a:t> and </a:t>
-            </a:r>
-            <a:r>
-              <a:rPr b="1"/>
-              <a:t>staff satisfaction decreasing</a:t>
-            </a:r>
-            <a:r>
-              <a:rPr/>
-              <a:t>.</a:t>
-            </a:r>
-          </a:p>
-          <a:p>
-            <a:pPr lvl="0" indent="0" marL="0">
-              <a:buNone/>
-            </a:pPr>
-            <a:r>
-              <a:rPr/>
-              <a:t>This suggests that there are many factors in the hospital design, systems, policies and cultures that are important. </a:t>
-            </a:r>
-            <a:r>
-              <a:rPr i="1"/>
-              <a:t>Responses to a qualitative look-back exercise are still being explored to identify those critical factors that are likely to have exacerbated success or failure</a:t>
-            </a:r>
-            <a:r>
-              <a:rPr/>
-              <a:t>.</a:t>
-            </a:r>
-          </a:p>
-          <a:p>
-            <a:pPr lvl="0" indent="0" marL="0">
-              <a:buNone/>
-            </a:pPr>
-            <a:r>
-              <a:rPr/>
-              <a:t>Switching to single bedroom hospitals without considering these other factors would not necessarily have a positive effect on outcomes nor mitigate any likely risks.</a:t>
+            <a:pPr lvl="0"/>
+            <a:r>
+              <a:rPr/>
+              <a:t>Previous literature reviews and general searches were undertaken to identify potential impact factors.</a:t>
+            </a:r>
+          </a:p>
+          <a:p>
+            <a:pPr lvl="0"/>
+            <a:r>
+              <a:rPr/>
+              <a:t>Identified relevant measures or proxy measures from publicly available data and routine data sources.</a:t>
+            </a:r>
+          </a:p>
+          <a:p>
+            <a:pPr lvl="0"/>
+            <a:r>
+              <a:rPr/>
+              <a:t>Included only those with sufficient time series and of acceptable data quality into final impact framework.</a:t>
+            </a:r>
+          </a:p>
+          <a:p>
+            <a:pPr lvl="0"/>
+            <a:r>
+              <a:rPr/>
+              <a:t>Cleansed and compiled all the data into time series format.</a:t>
+            </a:r>
+          </a:p>
+        </p:txBody>
+      </p:sp>
+      <p:sp>
+        <p:nvSpPr>
+          <p:cNvPr id="4" name="Content Placeholder 2">
+            <a:extLst>
+              <a:ext uri="{FF2B5EF4-FFF2-40B4-BE49-F238E27FC236}">
+                <a16:creationId xmlns:a16="http://schemas.microsoft.com/office/drawing/2014/main" id="{D1BAB7DA-EC53-0103-E362-83F86BDB6BC4}"/>
+              </a:ext>
+            </a:extLst>
+          </p:cNvPr>
+          <p:cNvSpPr>
+            <a:spLocks noGrp="1"/>
+          </p:cNvSpPr>
+          <p:nvPr>
+            <p:ph idx="11"/>
+          </p:nvPr>
+        </p:nvSpPr>
+        <p:spPr/>
+        <p:txBody>
+          <a:bodyPr/>
+          <a:lstStyle/>
+          <a:p>
+            <a:pPr lvl="0"/>
+            <a:r>
+              <a:rPr/>
+              <a:t>Identified ‘control’ sites and providers to compare to our natural experiment sites - matching according to hospital function, size, case-mix and admission ratio’s.</a:t>
+            </a:r>
+          </a:p>
+          <a:p>
+            <a:pPr lvl="0"/>
+            <a:r>
+              <a:rPr/>
+              <a:t>Performed causal impact analysis on the pre and post intervention periods to detect the nature and scale of impacts for each natural experiment.</a:t>
+            </a:r>
+          </a:p>
+          <a:p>
+            <a:pPr lvl="0"/>
+            <a:r>
+              <a:rPr/>
+              <a:t>Aggregated findings for the non-specialist hospitals.</a:t>
             </a:r>
           </a:p>
         </p:txBody>
@@ -8397,8 +8419,8 @@
         </p:nvSpPr>
         <p:spPr>
           <a:xfrm>
-            <a:off x="909829" y="438150"/>
-            <a:ext cx="8434196" cy="914400"/>
+            <a:off x="909829" y="403765"/>
+            <a:ext cx="8434196" cy="976056"/>
           </a:xfrm>
         </p:spPr>
         <p:txBody>
@@ -8410,25 +8432,19 @@
             </a:pPr>
             <a:r>
               <a:rPr/>
-              <a:t>2.4 Summary of key findings (2)</a:t>
-            </a:r>
-          </a:p>
-        </p:txBody>
-      </p:sp>
-      <p:sp>
-        <p:nvSpPr>
-          <p:cNvPr id="7" name="Text Placeholder 6">
-            <a:extLst>
-              <a:ext uri="{FF2B5EF4-FFF2-40B4-BE49-F238E27FC236}">
-                <a16:creationId xmlns:a16="http://schemas.microsoft.com/office/drawing/2014/main" id="{DE622849-4EA7-24AE-DD96-E693EAA81594}"/>
-              </a:ext>
-            </a:extLst>
-          </p:cNvPr>
-          <p:cNvSpPr>
-            <a:spLocks noGrp="1"/>
-          </p:cNvSpPr>
-          <p:nvPr>
-            <p:ph idx="13" sz="quarter" type="body"/>
+              <a:t>2.3 Summary of key findings (1)</a:t>
+            </a:r>
+          </a:p>
+        </p:txBody>
+      </p:sp>
+      <p:sp>
+        <p:nvSpPr>
+          <p:cNvPr id="3" name="Content Placeholder 2"/>
+          <p:cNvSpPr>
+            <a:spLocks noGrp="1"/>
+          </p:cNvSpPr>
+          <p:nvPr>
+            <p:ph idx="1"/>
           </p:nvPr>
         </p:nvSpPr>
         <p:spPr/>
@@ -8441,41 +8457,61 @@
             </a:pPr>
             <a:r>
               <a:rPr/>
-              <a:t>The table across demonstrates the range of impacts across all new hospital sites for each impact measure</a:t>
-            </a:r>
-          </a:p>
-        </p:txBody>
-      </p:sp>
-      <p:pic>
-        <p:nvPicPr>
-          <p:cNvPr descr="images/impact_range.jpeg" id="0" name="Picture 1"/>
-          <p:cNvPicPr>
-            <a:picLocks noGrp="1" noChangeAspect="1"/>
-          </p:cNvPicPr>
-          <p:nvPr/>
-        </p:nvPicPr>
-        <p:blipFill>
-          <a:blip r:embed="rId2"/>
-          <a:stretch>
-            <a:fillRect/>
-          </a:stretch>
-        </p:blipFill>
-        <p:spPr bwMode="auto">
-          <a:xfrm>
-            <a:off x="4127500" y="2374900"/>
-            <a:ext cx="7010400" cy="2616200"/>
-          </a:xfrm>
-          <a:prstGeom prst="rect">
-            <a:avLst/>
-          </a:prstGeom>
-          <a:noFill/>
-          <a:ln w="9525">
-            <a:noFill/>
-            <a:headEnd/>
-            <a:tailEnd/>
-          </a:ln>
-        </p:spPr>
-      </p:pic>
+              <a:t>Our results are generally not consistent within indicators and across hospital sites. This inconsistency is reflective of the findings from published literature. Only one impact measure moved in the same direction across all (eligible) sites - </a:t>
+            </a:r>
+            <a:r>
+              <a:rPr b="1"/>
+              <a:t>staff turnover decreasing</a:t>
+            </a:r>
+            <a:r>
+              <a:rPr/>
+              <a:t> and two measures were significant at the pooled general-acute hospital level - </a:t>
+            </a:r>
+            <a:r>
+              <a:rPr b="1"/>
+              <a:t>staff sickness increasing</a:t>
+            </a:r>
+            <a:r>
+              <a:rPr/>
+              <a:t> and </a:t>
+            </a:r>
+            <a:r>
+              <a:rPr b="1"/>
+              <a:t>staff satisfaction decreasing</a:t>
+            </a:r>
+            <a:r>
+              <a:rPr/>
+              <a:t>.</a:t>
+            </a:r>
+          </a:p>
+          <a:p>
+            <a:pPr lvl="0" indent="0" marL="0">
+              <a:buNone/>
+            </a:pPr>
+            <a:r>
+              <a:rPr/>
+              <a:t>This suggests that there are many factors in the hospital design, systems, policies and cultures that are important. </a:t>
+            </a:r>
+            <a:r>
+              <a:rPr i="1"/>
+              <a:t>Responses to a qualitative look-back exercise are still being explored to identify those critical factors that are likely to have exacerbated success or failure</a:t>
+            </a:r>
+            <a:r>
+              <a:rPr/>
+              <a:t>.</a:t>
+            </a:r>
+          </a:p>
+          <a:p>
+            <a:pPr lvl="0" indent="0" marL="0">
+              <a:buNone/>
+            </a:pPr>
+            <a:r>
+              <a:rPr/>
+              <a:t>Switching to single bedroom hospitals without considering these other factors would not necessarily have a positive effect on outcomes nor mitigate any likely risks.</a:t>
+            </a:r>
+          </a:p>
+        </p:txBody>
+      </p:sp>
     </p:spTree>
   </p:cSld>
 </p:sld>

</xml_diff>